<commit_message>
Keep only deck v2, v3, and cream tech report; remove older PPTX.
Co-authored-by: Cursor <cursoragent@cursor.com>
</commit_message>
<xml_diff>
--- a/docs/CampusAI-TechReport-cream.pptx
+++ b/docs/CampusAI-TechReport-cream.pptx
@@ -4,18 +4,21 @@
   <p:sldMasterIdLst>
     <p:sldMasterId id="2147483648" r:id="rId1"/>
   </p:sldMasterIdLst>
+  <p:notesMasterIdLst>
+    <p:notesMasterId r:id="rId11"/>
+  </p:notesMasterIdLst>
   <p:sldIdLst>
-    <p:sldId id="256" r:id="rId7"/>
-    <p:sldId id="257" r:id="rId8"/>
-    <p:sldId id="258" r:id="rId9"/>
-    <p:sldId id="259" r:id="rId10"/>
-    <p:sldId id="260" r:id="rId11"/>
-    <p:sldId id="261" r:id="rId12"/>
-    <p:sldId id="262" r:id="rId13"/>
-    <p:sldId id="263" r:id="rId14"/>
-    <p:sldId id="264" r:id="rId15"/>
+    <p:sldId id="256" r:id="rId2"/>
+    <p:sldId id="257" r:id="rId3"/>
+    <p:sldId id="258" r:id="rId4"/>
+    <p:sldId id="259" r:id="rId5"/>
+    <p:sldId id="260" r:id="rId6"/>
+    <p:sldId id="261" r:id="rId7"/>
+    <p:sldId id="262" r:id="rId8"/>
+    <p:sldId id="263" r:id="rId9"/>
+    <p:sldId id="264" r:id="rId10"/>
   </p:sldIdLst>
-  <p:sldSz cx="12191695" cy="6858000" type="screen4x3"/>
+  <p:sldSz cx="12192000" cy="6858000"/>
   <p:notesSz cx="6858000" cy="9144000"/>
   <p:defaultTextStyle>
     <a:defPPr>
@@ -112,7 +115,540 @@
       </a:defRPr>
     </a:lvl9pPr>
   </p:defaultTextStyle>
+  <p:extLst>
+    <p:ext uri="{EFAFB233-063F-42B5-8137-9DF3F51BA10A}">
+      <p15:sldGuideLst xmlns:p15="http://schemas.microsoft.com/office/powerpoint/2012/main">
+        <p15:guide id="1" orient="horz" pos="2160">
+          <p15:clr>
+            <a:srgbClr val="A4A3A4"/>
+          </p15:clr>
+        </p15:guide>
+        <p15:guide id="2" pos="2880">
+          <p15:clr>
+            <a:srgbClr val="A4A3A4"/>
+          </p15:clr>
+        </p15:guide>
+      </p15:sldGuideLst>
+    </p:ext>
+  </p:extLst>
 </p:presentation>
+</file>
+
+<file path=ppt/notesMasters/notesMaster1.xml><?xml version="1.0" encoding="utf-8"?>
+<p:notesMaster xmlns:a="http://schemas.openxmlformats.org/drawingml/2006/main" xmlns:r="http://schemas.openxmlformats.org/officeDocument/2006/relationships" xmlns:p="http://schemas.openxmlformats.org/presentationml/2006/main">
+  <p:cSld>
+    <p:bg>
+      <p:bgRef idx="1001">
+        <a:schemeClr val="bg1"/>
+      </p:bgRef>
+    </p:bg>
+    <p:spTree>
+      <p:nvGrpSpPr>
+        <p:cNvPr id="1" name=""/>
+        <p:cNvGrpSpPr/>
+        <p:nvPr/>
+      </p:nvGrpSpPr>
+      <p:grpSpPr>
+        <a:xfrm>
+          <a:off x="0" y="0"/>
+          <a:ext cx="0" cy="0"/>
+          <a:chOff x="0" y="0"/>
+          <a:chExt cx="0" cy="0"/>
+        </a:xfrm>
+      </p:grpSpPr>
+      <p:sp>
+        <p:nvSpPr>
+          <p:cNvPr id="2" name="頁首版面配置區 1"/>
+          <p:cNvSpPr>
+            <a:spLocks noGrp="1"/>
+          </p:cNvSpPr>
+          <p:nvPr>
+            <p:ph type="hdr" sz="quarter"/>
+          </p:nvPr>
+        </p:nvSpPr>
+        <p:spPr>
+          <a:xfrm>
+            <a:off x="0" y="0"/>
+            <a:ext cx="2971800" cy="458788"/>
+          </a:xfrm>
+          <a:prstGeom prst="rect">
+            <a:avLst/>
+          </a:prstGeom>
+        </p:spPr>
+        <p:txBody>
+          <a:bodyPr vert="horz" lIns="91440" tIns="45720" rIns="91440" bIns="45720" rtlCol="0"/>
+          <a:lstStyle>
+            <a:lvl1pPr algn="l">
+              <a:defRPr sz="1200"/>
+            </a:lvl1pPr>
+          </a:lstStyle>
+          <a:p>
+            <a:endParaRPr lang="zh-TW" altLang="en-US"/>
+          </a:p>
+        </p:txBody>
+      </p:sp>
+      <p:sp>
+        <p:nvSpPr>
+          <p:cNvPr id="3" name="日期版面配置區 2"/>
+          <p:cNvSpPr>
+            <a:spLocks noGrp="1"/>
+          </p:cNvSpPr>
+          <p:nvPr>
+            <p:ph type="dt" idx="1"/>
+          </p:nvPr>
+        </p:nvSpPr>
+        <p:spPr>
+          <a:xfrm>
+            <a:off x="3884613" y="0"/>
+            <a:ext cx="2971800" cy="458788"/>
+          </a:xfrm>
+          <a:prstGeom prst="rect">
+            <a:avLst/>
+          </a:prstGeom>
+        </p:spPr>
+        <p:txBody>
+          <a:bodyPr vert="horz" lIns="91440" tIns="45720" rIns="91440" bIns="45720" rtlCol="0"/>
+          <a:lstStyle>
+            <a:lvl1pPr algn="r">
+              <a:defRPr sz="1200"/>
+            </a:lvl1pPr>
+          </a:lstStyle>
+          <a:p>
+            <a:fld id="{84AEC38E-7396-4A29-8862-66B126203FD5}" type="datetimeFigureOut">
+              <a:rPr lang="zh-TW" altLang="en-US" smtClean="0"/>
+              <a:t>2026/9/14</a:t>
+            </a:fld>
+            <a:endParaRPr lang="zh-TW" altLang="en-US"/>
+          </a:p>
+        </p:txBody>
+      </p:sp>
+      <p:sp>
+        <p:nvSpPr>
+          <p:cNvPr id="4" name="投影片影像版面配置區 3"/>
+          <p:cNvSpPr>
+            <a:spLocks noGrp="1" noRot="1" noChangeAspect="1"/>
+          </p:cNvSpPr>
+          <p:nvPr>
+            <p:ph type="sldImg" idx="2"/>
+          </p:nvPr>
+        </p:nvSpPr>
+        <p:spPr>
+          <a:xfrm>
+            <a:off x="685800" y="1143000"/>
+            <a:ext cx="5486400" cy="3086100"/>
+          </a:xfrm>
+          <a:prstGeom prst="rect">
+            <a:avLst/>
+          </a:prstGeom>
+          <a:noFill/>
+          <a:ln w="12700">
+            <a:solidFill>
+              <a:prstClr val="black"/>
+            </a:solidFill>
+          </a:ln>
+        </p:spPr>
+        <p:txBody>
+          <a:bodyPr vert="horz" lIns="91440" tIns="45720" rIns="91440" bIns="45720" rtlCol="0" anchor="ctr"/>
+          <a:lstStyle/>
+          <a:p>
+            <a:endParaRPr lang="zh-TW" altLang="en-US"/>
+          </a:p>
+        </p:txBody>
+      </p:sp>
+      <p:sp>
+        <p:nvSpPr>
+          <p:cNvPr id="5" name="備忘稿版面配置區 4"/>
+          <p:cNvSpPr>
+            <a:spLocks noGrp="1"/>
+          </p:cNvSpPr>
+          <p:nvPr>
+            <p:ph type="body" sz="quarter" idx="3"/>
+          </p:nvPr>
+        </p:nvSpPr>
+        <p:spPr>
+          <a:xfrm>
+            <a:off x="685800" y="4400550"/>
+            <a:ext cx="5486400" cy="3600450"/>
+          </a:xfrm>
+          <a:prstGeom prst="rect">
+            <a:avLst/>
+          </a:prstGeom>
+        </p:spPr>
+        <p:txBody>
+          <a:bodyPr vert="horz" lIns="91440" tIns="45720" rIns="91440" bIns="45720" rtlCol="0"/>
+          <a:lstStyle/>
+          <a:p>
+            <a:pPr lvl="0"/>
+            <a:r>
+              <a:rPr lang="zh-TW" altLang="en-US"/>
+              <a:t>按一下以編輯母片文字樣式</a:t>
+            </a:r>
+          </a:p>
+          <a:p>
+            <a:pPr lvl="1"/>
+            <a:r>
+              <a:rPr lang="zh-TW" altLang="en-US"/>
+              <a:t>第二層</a:t>
+            </a:r>
+          </a:p>
+          <a:p>
+            <a:pPr lvl="2"/>
+            <a:r>
+              <a:rPr lang="zh-TW" altLang="en-US"/>
+              <a:t>第三層</a:t>
+            </a:r>
+          </a:p>
+          <a:p>
+            <a:pPr lvl="3"/>
+            <a:r>
+              <a:rPr lang="zh-TW" altLang="en-US"/>
+              <a:t>第四層</a:t>
+            </a:r>
+          </a:p>
+          <a:p>
+            <a:pPr lvl="4"/>
+            <a:r>
+              <a:rPr lang="zh-TW" altLang="en-US"/>
+              <a:t>第五層</a:t>
+            </a:r>
+          </a:p>
+        </p:txBody>
+      </p:sp>
+      <p:sp>
+        <p:nvSpPr>
+          <p:cNvPr id="6" name="頁尾版面配置區 5"/>
+          <p:cNvSpPr>
+            <a:spLocks noGrp="1"/>
+          </p:cNvSpPr>
+          <p:nvPr>
+            <p:ph type="ftr" sz="quarter" idx="4"/>
+          </p:nvPr>
+        </p:nvSpPr>
+        <p:spPr>
+          <a:xfrm>
+            <a:off x="0" y="8685213"/>
+            <a:ext cx="2971800" cy="458787"/>
+          </a:xfrm>
+          <a:prstGeom prst="rect">
+            <a:avLst/>
+          </a:prstGeom>
+        </p:spPr>
+        <p:txBody>
+          <a:bodyPr vert="horz" lIns="91440" tIns="45720" rIns="91440" bIns="45720" rtlCol="0" anchor="b"/>
+          <a:lstStyle>
+            <a:lvl1pPr algn="l">
+              <a:defRPr sz="1200"/>
+            </a:lvl1pPr>
+          </a:lstStyle>
+          <a:p>
+            <a:endParaRPr lang="zh-TW" altLang="en-US"/>
+          </a:p>
+        </p:txBody>
+      </p:sp>
+      <p:sp>
+        <p:nvSpPr>
+          <p:cNvPr id="7" name="投影片編號版面配置區 6"/>
+          <p:cNvSpPr>
+            <a:spLocks noGrp="1"/>
+          </p:cNvSpPr>
+          <p:nvPr>
+            <p:ph type="sldNum" sz="quarter" idx="5"/>
+          </p:nvPr>
+        </p:nvSpPr>
+        <p:spPr>
+          <a:xfrm>
+            <a:off x="3884613" y="8685213"/>
+            <a:ext cx="2971800" cy="458787"/>
+          </a:xfrm>
+          <a:prstGeom prst="rect">
+            <a:avLst/>
+          </a:prstGeom>
+        </p:spPr>
+        <p:txBody>
+          <a:bodyPr vert="horz" lIns="91440" tIns="45720" rIns="91440" bIns="45720" rtlCol="0" anchor="b"/>
+          <a:lstStyle>
+            <a:lvl1pPr algn="r">
+              <a:defRPr sz="1200"/>
+            </a:lvl1pPr>
+          </a:lstStyle>
+          <a:p>
+            <a:fld id="{EE1C11A7-C0BF-4815-9B46-43BBA3DBFF84}" type="slidenum">
+              <a:rPr lang="zh-TW" altLang="en-US" smtClean="0"/>
+              <a:t>‹#›</a:t>
+            </a:fld>
+            <a:endParaRPr lang="zh-TW" altLang="en-US"/>
+          </a:p>
+        </p:txBody>
+      </p:sp>
+    </p:spTree>
+    <p:extLst>
+      <p:ext uri="{BB962C8B-B14F-4D97-AF65-F5344CB8AC3E}">
+        <p14:creationId xmlns:p14="http://schemas.microsoft.com/office/powerpoint/2010/main" val="1974613805"/>
+      </p:ext>
+    </p:extLst>
+  </p:cSld>
+  <p:clrMap bg1="lt1" tx1="dk1" bg2="lt2" tx2="dk2" accent1="accent1" accent2="accent2" accent3="accent3" accent4="accent4" accent5="accent5" accent6="accent6" hlink="hlink" folHlink="folHlink"/>
+  <p:notesStyle>
+    <a:lvl1pPr marL="0" algn="l" defTabSz="914400" rtl="0" eaLnBrk="1" latinLnBrk="0" hangingPunct="1">
+      <a:defRPr sz="1200" kern="1200">
+        <a:solidFill>
+          <a:schemeClr val="tx1"/>
+        </a:solidFill>
+        <a:latin typeface="+mn-lt"/>
+        <a:ea typeface="+mn-ea"/>
+        <a:cs typeface="+mn-cs"/>
+      </a:defRPr>
+    </a:lvl1pPr>
+    <a:lvl2pPr marL="457200" algn="l" defTabSz="914400" rtl="0" eaLnBrk="1" latinLnBrk="0" hangingPunct="1">
+      <a:defRPr sz="1200" kern="1200">
+        <a:solidFill>
+          <a:schemeClr val="tx1"/>
+        </a:solidFill>
+        <a:latin typeface="+mn-lt"/>
+        <a:ea typeface="+mn-ea"/>
+        <a:cs typeface="+mn-cs"/>
+      </a:defRPr>
+    </a:lvl2pPr>
+    <a:lvl3pPr marL="914400" algn="l" defTabSz="914400" rtl="0" eaLnBrk="1" latinLnBrk="0" hangingPunct="1">
+      <a:defRPr sz="1200" kern="1200">
+        <a:solidFill>
+          <a:schemeClr val="tx1"/>
+        </a:solidFill>
+        <a:latin typeface="+mn-lt"/>
+        <a:ea typeface="+mn-ea"/>
+        <a:cs typeface="+mn-cs"/>
+      </a:defRPr>
+    </a:lvl3pPr>
+    <a:lvl4pPr marL="1371600" algn="l" defTabSz="914400" rtl="0" eaLnBrk="1" latinLnBrk="0" hangingPunct="1">
+      <a:defRPr sz="1200" kern="1200">
+        <a:solidFill>
+          <a:schemeClr val="tx1"/>
+        </a:solidFill>
+        <a:latin typeface="+mn-lt"/>
+        <a:ea typeface="+mn-ea"/>
+        <a:cs typeface="+mn-cs"/>
+      </a:defRPr>
+    </a:lvl4pPr>
+    <a:lvl5pPr marL="1828800" algn="l" defTabSz="914400" rtl="0" eaLnBrk="1" latinLnBrk="0" hangingPunct="1">
+      <a:defRPr sz="1200" kern="1200">
+        <a:solidFill>
+          <a:schemeClr val="tx1"/>
+        </a:solidFill>
+        <a:latin typeface="+mn-lt"/>
+        <a:ea typeface="+mn-ea"/>
+        <a:cs typeface="+mn-cs"/>
+      </a:defRPr>
+    </a:lvl5pPr>
+    <a:lvl6pPr marL="2286000" algn="l" defTabSz="914400" rtl="0" eaLnBrk="1" latinLnBrk="0" hangingPunct="1">
+      <a:defRPr sz="1200" kern="1200">
+        <a:solidFill>
+          <a:schemeClr val="tx1"/>
+        </a:solidFill>
+        <a:latin typeface="+mn-lt"/>
+        <a:ea typeface="+mn-ea"/>
+        <a:cs typeface="+mn-cs"/>
+      </a:defRPr>
+    </a:lvl6pPr>
+    <a:lvl7pPr marL="2743200" algn="l" defTabSz="914400" rtl="0" eaLnBrk="1" latinLnBrk="0" hangingPunct="1">
+      <a:defRPr sz="1200" kern="1200">
+        <a:solidFill>
+          <a:schemeClr val="tx1"/>
+        </a:solidFill>
+        <a:latin typeface="+mn-lt"/>
+        <a:ea typeface="+mn-ea"/>
+        <a:cs typeface="+mn-cs"/>
+      </a:defRPr>
+    </a:lvl7pPr>
+    <a:lvl8pPr marL="3200400" algn="l" defTabSz="914400" rtl="0" eaLnBrk="1" latinLnBrk="0" hangingPunct="1">
+      <a:defRPr sz="1200" kern="1200">
+        <a:solidFill>
+          <a:schemeClr val="tx1"/>
+        </a:solidFill>
+        <a:latin typeface="+mn-lt"/>
+        <a:ea typeface="+mn-ea"/>
+        <a:cs typeface="+mn-cs"/>
+      </a:defRPr>
+    </a:lvl8pPr>
+    <a:lvl9pPr marL="3657600" algn="l" defTabSz="914400" rtl="0" eaLnBrk="1" latinLnBrk="0" hangingPunct="1">
+      <a:defRPr sz="1200" kern="1200">
+        <a:solidFill>
+          <a:schemeClr val="tx1"/>
+        </a:solidFill>
+        <a:latin typeface="+mn-lt"/>
+        <a:ea typeface="+mn-ea"/>
+        <a:cs typeface="+mn-cs"/>
+      </a:defRPr>
+    </a:lvl9pPr>
+  </p:notesStyle>
+</p:notesMaster>
+</file>
+
+<file path=ppt/notesSlides/notesSlide1.xml><?xml version="1.0" encoding="utf-8"?>
+<p:notes xmlns:a="http://schemas.openxmlformats.org/drawingml/2006/main" xmlns:r="http://schemas.openxmlformats.org/officeDocument/2006/relationships" xmlns:p="http://schemas.openxmlformats.org/presentationml/2006/main">
+  <p:cSld>
+    <p:spTree>
+      <p:nvGrpSpPr>
+        <p:cNvPr id="1" name=""/>
+        <p:cNvGrpSpPr/>
+        <p:nvPr/>
+      </p:nvGrpSpPr>
+      <p:grpSpPr>
+        <a:xfrm>
+          <a:off x="0" y="0"/>
+          <a:ext cx="0" cy="0"/>
+          <a:chOff x="0" y="0"/>
+          <a:chExt cx="0" cy="0"/>
+        </a:xfrm>
+      </p:grpSpPr>
+      <p:sp>
+        <p:nvSpPr>
+          <p:cNvPr id="2" name="投影片影像版面配置區 1"/>
+          <p:cNvSpPr>
+            <a:spLocks noGrp="1" noRot="1" noChangeAspect="1"/>
+          </p:cNvSpPr>
+          <p:nvPr>
+            <p:ph type="sldImg"/>
+          </p:nvPr>
+        </p:nvSpPr>
+        <p:spPr/>
+      </p:sp>
+      <p:sp>
+        <p:nvSpPr>
+          <p:cNvPr id="3" name="備忘稿版面配置區 2"/>
+          <p:cNvSpPr>
+            <a:spLocks noGrp="1"/>
+          </p:cNvSpPr>
+          <p:nvPr>
+            <p:ph type="body" idx="1"/>
+          </p:nvPr>
+        </p:nvSpPr>
+        <p:spPr/>
+        <p:txBody>
+          <a:bodyPr/>
+          <a:lstStyle/>
+          <a:p>
+            <a:endParaRPr lang="zh-TW" altLang="en-US" dirty="0"/>
+          </a:p>
+        </p:txBody>
+      </p:sp>
+      <p:sp>
+        <p:nvSpPr>
+          <p:cNvPr id="4" name="投影片編號版面配置區 3"/>
+          <p:cNvSpPr>
+            <a:spLocks noGrp="1"/>
+          </p:cNvSpPr>
+          <p:nvPr>
+            <p:ph type="sldNum" sz="quarter" idx="5"/>
+          </p:nvPr>
+        </p:nvSpPr>
+        <p:spPr/>
+        <p:txBody>
+          <a:bodyPr/>
+          <a:lstStyle/>
+          <a:p>
+            <a:fld id="{EE1C11A7-C0BF-4815-9B46-43BBA3DBFF84}" type="slidenum">
+              <a:rPr lang="zh-TW" altLang="en-US" smtClean="0"/>
+              <a:t>2</a:t>
+            </a:fld>
+            <a:endParaRPr lang="zh-TW" altLang="en-US"/>
+          </a:p>
+        </p:txBody>
+      </p:sp>
+    </p:spTree>
+    <p:extLst>
+      <p:ext uri="{BB962C8B-B14F-4D97-AF65-F5344CB8AC3E}">
+        <p14:creationId xmlns:p14="http://schemas.microsoft.com/office/powerpoint/2010/main" val="1850814027"/>
+      </p:ext>
+    </p:extLst>
+  </p:cSld>
+  <p:clrMapOvr>
+    <a:masterClrMapping/>
+  </p:clrMapOvr>
+</p:notes>
+</file>
+
+<file path=ppt/notesSlides/notesSlide2.xml><?xml version="1.0" encoding="utf-8"?>
+<p:notes xmlns:a="http://schemas.openxmlformats.org/drawingml/2006/main" xmlns:r="http://schemas.openxmlformats.org/officeDocument/2006/relationships" xmlns:p="http://schemas.openxmlformats.org/presentationml/2006/main">
+  <p:cSld>
+    <p:spTree>
+      <p:nvGrpSpPr>
+        <p:cNvPr id="1" name=""/>
+        <p:cNvGrpSpPr/>
+        <p:nvPr/>
+      </p:nvGrpSpPr>
+      <p:grpSpPr>
+        <a:xfrm>
+          <a:off x="0" y="0"/>
+          <a:ext cx="0" cy="0"/>
+          <a:chOff x="0" y="0"/>
+          <a:chExt cx="0" cy="0"/>
+        </a:xfrm>
+      </p:grpSpPr>
+      <p:sp>
+        <p:nvSpPr>
+          <p:cNvPr id="2" name="投影片影像版面配置區 1"/>
+          <p:cNvSpPr>
+            <a:spLocks noGrp="1" noRot="1" noChangeAspect="1"/>
+          </p:cNvSpPr>
+          <p:nvPr>
+            <p:ph type="sldImg"/>
+          </p:nvPr>
+        </p:nvSpPr>
+        <p:spPr/>
+      </p:sp>
+      <p:sp>
+        <p:nvSpPr>
+          <p:cNvPr id="3" name="備忘稿版面配置區 2"/>
+          <p:cNvSpPr>
+            <a:spLocks noGrp="1"/>
+          </p:cNvSpPr>
+          <p:nvPr>
+            <p:ph type="body" idx="1"/>
+          </p:nvPr>
+        </p:nvSpPr>
+        <p:spPr/>
+        <p:txBody>
+          <a:bodyPr/>
+          <a:lstStyle/>
+          <a:p>
+            <a:endParaRPr lang="zh-TW" altLang="en-US" dirty="0"/>
+          </a:p>
+        </p:txBody>
+      </p:sp>
+      <p:sp>
+        <p:nvSpPr>
+          <p:cNvPr id="4" name="投影片編號版面配置區 3"/>
+          <p:cNvSpPr>
+            <a:spLocks noGrp="1"/>
+          </p:cNvSpPr>
+          <p:nvPr>
+            <p:ph type="sldNum" sz="quarter" idx="5"/>
+          </p:nvPr>
+        </p:nvSpPr>
+        <p:spPr/>
+        <p:txBody>
+          <a:bodyPr/>
+          <a:lstStyle/>
+          <a:p>
+            <a:fld id="{EE1C11A7-C0BF-4815-9B46-43BBA3DBFF84}" type="slidenum">
+              <a:rPr lang="zh-TW" altLang="en-US" smtClean="0"/>
+              <a:t>5</a:t>
+            </a:fld>
+            <a:endParaRPr lang="zh-TW" altLang="en-US"/>
+          </a:p>
+        </p:txBody>
+      </p:sp>
+    </p:spTree>
+    <p:extLst>
+      <p:ext uri="{BB962C8B-B14F-4D97-AF65-F5344CB8AC3E}">
+        <p14:creationId xmlns:p14="http://schemas.microsoft.com/office/powerpoint/2010/main" val="403078962"/>
+      </p:ext>
+    </p:extLst>
+  </p:cSld>
+  <p:clrMapOvr>
+    <a:masterClrMapping/>
+  </p:clrMapOvr>
+</p:notes>
 </file>
 
 <file path=ppt/slideLayouts/slideLayout1.xml><?xml version="1.0" encoding="utf-8"?>
@@ -153,10 +689,9 @@
           <a:lstStyle/>
           <a:p>
             <a:r>
-              <a:rPr lang="en-US" smtClean="0"/>
+              <a:rPr lang="en-US"/>
               <a:t>Click to edit Master title style</a:t>
             </a:r>
-            <a:endParaRPr lang="en-US"/>
           </a:p>
         </p:txBody>
       </p:sp>
@@ -272,10 +807,9 @@
           </a:lstStyle>
           <a:p>
             <a:r>
-              <a:rPr lang="en-US" smtClean="0"/>
+              <a:rPr lang="en-US"/>
               <a:t>Click to edit Master subtitle style</a:t>
             </a:r>
-            <a:endParaRPr lang="en-US"/>
           </a:p>
         </p:txBody>
       </p:sp>
@@ -296,7 +830,7 @@
           <a:p>
             <a:fld id="{5BCAD085-E8A6-8845-BD4E-CB4CCA059FC4}" type="datetimeFigureOut">
               <a:rPr lang="en-US" smtClean="0"/>
-              <a:t>1/27/13</a:t>
+              <a:t>9/14/2026</a:t>
             </a:fld>
             <a:endParaRPr lang="en-US"/>
           </a:p>
@@ -390,10 +924,9 @@
           <a:lstStyle/>
           <a:p>
             <a:r>
-              <a:rPr lang="en-US" smtClean="0"/>
+              <a:rPr lang="en-US"/>
               <a:t>Click to edit Master title style</a:t>
             </a:r>
-            <a:endParaRPr lang="en-US"/>
           </a:p>
         </p:txBody>
       </p:sp>
@@ -414,38 +947,37 @@
           <a:p>
             <a:pPr lvl="0"/>
             <a:r>
-              <a:rPr lang="en-US" smtClean="0"/>
+              <a:rPr lang="en-US"/>
               <a:t>Click to edit Master text styles</a:t>
             </a:r>
           </a:p>
           <a:p>
             <a:pPr lvl="1"/>
             <a:r>
-              <a:rPr lang="en-US" smtClean="0"/>
+              <a:rPr lang="en-US"/>
               <a:t>Second level</a:t>
             </a:r>
           </a:p>
           <a:p>
             <a:pPr lvl="2"/>
             <a:r>
-              <a:rPr lang="en-US" smtClean="0"/>
+              <a:rPr lang="en-US"/>
               <a:t>Third level</a:t>
             </a:r>
           </a:p>
           <a:p>
             <a:pPr lvl="3"/>
             <a:r>
-              <a:rPr lang="en-US" smtClean="0"/>
+              <a:rPr lang="en-US"/>
               <a:t>Fourth level</a:t>
             </a:r>
           </a:p>
           <a:p>
             <a:pPr lvl="4"/>
             <a:r>
-              <a:rPr lang="en-US" smtClean="0"/>
+              <a:rPr lang="en-US"/>
               <a:t>Fifth level</a:t>
             </a:r>
-            <a:endParaRPr lang="en-US"/>
           </a:p>
         </p:txBody>
       </p:sp>
@@ -466,7 +998,7 @@
           <a:p>
             <a:fld id="{5BCAD085-E8A6-8845-BD4E-CB4CCA059FC4}" type="datetimeFigureOut">
               <a:rPr lang="en-US" smtClean="0"/>
-              <a:t>1/27/13</a:t>
+              <a:t>9/14/2026</a:t>
             </a:fld>
             <a:endParaRPr lang="en-US"/>
           </a:p>
@@ -565,10 +1097,9 @@
           <a:lstStyle/>
           <a:p>
             <a:r>
-              <a:rPr lang="en-US" smtClean="0"/>
+              <a:rPr lang="en-US"/>
               <a:t>Click to edit Master title style</a:t>
             </a:r>
-            <a:endParaRPr lang="en-US"/>
           </a:p>
         </p:txBody>
       </p:sp>
@@ -594,38 +1125,37 @@
           <a:p>
             <a:pPr lvl="0"/>
             <a:r>
-              <a:rPr lang="en-US" smtClean="0"/>
+              <a:rPr lang="en-US"/>
               <a:t>Click to edit Master text styles</a:t>
             </a:r>
           </a:p>
           <a:p>
             <a:pPr lvl="1"/>
             <a:r>
-              <a:rPr lang="en-US" smtClean="0"/>
+              <a:rPr lang="en-US"/>
               <a:t>Second level</a:t>
             </a:r>
           </a:p>
           <a:p>
             <a:pPr lvl="2"/>
             <a:r>
-              <a:rPr lang="en-US" smtClean="0"/>
+              <a:rPr lang="en-US"/>
               <a:t>Third level</a:t>
             </a:r>
           </a:p>
           <a:p>
             <a:pPr lvl="3"/>
             <a:r>
-              <a:rPr lang="en-US" smtClean="0"/>
+              <a:rPr lang="en-US"/>
               <a:t>Fourth level</a:t>
             </a:r>
           </a:p>
           <a:p>
             <a:pPr lvl="4"/>
             <a:r>
-              <a:rPr lang="en-US" smtClean="0"/>
+              <a:rPr lang="en-US"/>
               <a:t>Fifth level</a:t>
             </a:r>
-            <a:endParaRPr lang="en-US"/>
           </a:p>
         </p:txBody>
       </p:sp>
@@ -646,7 +1176,7 @@
           <a:p>
             <a:fld id="{5BCAD085-E8A6-8845-BD4E-CB4CCA059FC4}" type="datetimeFigureOut">
               <a:rPr lang="en-US" smtClean="0"/>
-              <a:t>1/27/13</a:t>
+              <a:t>9/14/2026</a:t>
             </a:fld>
             <a:endParaRPr lang="en-US"/>
           </a:p>
@@ -740,10 +1270,9 @@
           <a:lstStyle/>
           <a:p>
             <a:r>
-              <a:rPr lang="en-US" smtClean="0"/>
+              <a:rPr lang="en-US"/>
               <a:t>Click to edit Master title style</a:t>
             </a:r>
-            <a:endParaRPr lang="en-US"/>
           </a:p>
         </p:txBody>
       </p:sp>
@@ -764,38 +1293,37 @@
           <a:p>
             <a:pPr lvl="0"/>
             <a:r>
-              <a:rPr lang="en-US" smtClean="0"/>
+              <a:rPr lang="en-US"/>
               <a:t>Click to edit Master text styles</a:t>
             </a:r>
           </a:p>
           <a:p>
             <a:pPr lvl="1"/>
             <a:r>
-              <a:rPr lang="en-US" smtClean="0"/>
+              <a:rPr lang="en-US"/>
               <a:t>Second level</a:t>
             </a:r>
           </a:p>
           <a:p>
             <a:pPr lvl="2"/>
             <a:r>
-              <a:rPr lang="en-US" smtClean="0"/>
+              <a:rPr lang="en-US"/>
               <a:t>Third level</a:t>
             </a:r>
           </a:p>
           <a:p>
             <a:pPr lvl="3"/>
             <a:r>
-              <a:rPr lang="en-US" smtClean="0"/>
+              <a:rPr lang="en-US"/>
               <a:t>Fourth level</a:t>
             </a:r>
           </a:p>
           <a:p>
             <a:pPr lvl="4"/>
             <a:r>
-              <a:rPr lang="en-US" smtClean="0"/>
+              <a:rPr lang="en-US"/>
               <a:t>Fifth level</a:t>
             </a:r>
-            <a:endParaRPr lang="en-US"/>
           </a:p>
         </p:txBody>
       </p:sp>
@@ -816,7 +1344,7 @@
           <a:p>
             <a:fld id="{5BCAD085-E8A6-8845-BD4E-CB4CCA059FC4}" type="datetimeFigureOut">
               <a:rPr lang="en-US" smtClean="0"/>
-              <a:t>1/27/13</a:t>
+              <a:t>9/14/2026</a:t>
             </a:fld>
             <a:endParaRPr lang="en-US"/>
           </a:p>
@@ -919,10 +1447,9 @@
           </a:lstStyle>
           <a:p>
             <a:r>
-              <a:rPr lang="en-US" smtClean="0"/>
+              <a:rPr lang="en-US"/>
               <a:t>Click to edit Master title style</a:t>
             </a:r>
-            <a:endParaRPr lang="en-US"/>
           </a:p>
         </p:txBody>
       </p:sp>
@@ -1039,7 +1566,7 @@
           <a:p>
             <a:pPr lvl="0"/>
             <a:r>
-              <a:rPr lang="en-US" smtClean="0"/>
+              <a:rPr lang="en-US"/>
               <a:t>Click to edit Master text styles</a:t>
             </a:r>
           </a:p>
@@ -1062,7 +1589,7 @@
           <a:p>
             <a:fld id="{5BCAD085-E8A6-8845-BD4E-CB4CCA059FC4}" type="datetimeFigureOut">
               <a:rPr lang="en-US" smtClean="0"/>
-              <a:t>1/27/13</a:t>
+              <a:t>9/14/2026</a:t>
             </a:fld>
             <a:endParaRPr lang="en-US"/>
           </a:p>
@@ -1156,10 +1683,9 @@
           <a:lstStyle/>
           <a:p>
             <a:r>
-              <a:rPr lang="en-US" smtClean="0"/>
+              <a:rPr lang="en-US"/>
               <a:t>Click to edit Master title style</a:t>
             </a:r>
-            <a:endParaRPr lang="en-US"/>
           </a:p>
         </p:txBody>
       </p:sp>
@@ -1213,38 +1739,37 @@
           <a:p>
             <a:pPr lvl="0"/>
             <a:r>
-              <a:rPr lang="en-US" smtClean="0"/>
+              <a:rPr lang="en-US"/>
               <a:t>Click to edit Master text styles</a:t>
             </a:r>
           </a:p>
           <a:p>
             <a:pPr lvl="1"/>
             <a:r>
-              <a:rPr lang="en-US" smtClean="0"/>
+              <a:rPr lang="en-US"/>
               <a:t>Second level</a:t>
             </a:r>
           </a:p>
           <a:p>
             <a:pPr lvl="2"/>
             <a:r>
-              <a:rPr lang="en-US" smtClean="0"/>
+              <a:rPr lang="en-US"/>
               <a:t>Third level</a:t>
             </a:r>
           </a:p>
           <a:p>
             <a:pPr lvl="3"/>
             <a:r>
-              <a:rPr lang="en-US" smtClean="0"/>
+              <a:rPr lang="en-US"/>
               <a:t>Fourth level</a:t>
             </a:r>
           </a:p>
           <a:p>
             <a:pPr lvl="4"/>
             <a:r>
-              <a:rPr lang="en-US" smtClean="0"/>
+              <a:rPr lang="en-US"/>
               <a:t>Fifth level</a:t>
             </a:r>
-            <a:endParaRPr lang="en-US"/>
           </a:p>
         </p:txBody>
       </p:sp>
@@ -1298,38 +1823,37 @@
           <a:p>
             <a:pPr lvl="0"/>
             <a:r>
-              <a:rPr lang="en-US" smtClean="0"/>
+              <a:rPr lang="en-US"/>
               <a:t>Click to edit Master text styles</a:t>
             </a:r>
           </a:p>
           <a:p>
             <a:pPr lvl="1"/>
             <a:r>
-              <a:rPr lang="en-US" smtClean="0"/>
+              <a:rPr lang="en-US"/>
               <a:t>Second level</a:t>
             </a:r>
           </a:p>
           <a:p>
             <a:pPr lvl="2"/>
             <a:r>
-              <a:rPr lang="en-US" smtClean="0"/>
+              <a:rPr lang="en-US"/>
               <a:t>Third level</a:t>
             </a:r>
           </a:p>
           <a:p>
             <a:pPr lvl="3"/>
             <a:r>
-              <a:rPr lang="en-US" smtClean="0"/>
+              <a:rPr lang="en-US"/>
               <a:t>Fourth level</a:t>
             </a:r>
           </a:p>
           <a:p>
             <a:pPr lvl="4"/>
             <a:r>
-              <a:rPr lang="en-US" smtClean="0"/>
+              <a:rPr lang="en-US"/>
               <a:t>Fifth level</a:t>
             </a:r>
-            <a:endParaRPr lang="en-US"/>
           </a:p>
         </p:txBody>
       </p:sp>
@@ -1350,7 +1874,7 @@
           <a:p>
             <a:fld id="{5BCAD085-E8A6-8845-BD4E-CB4CCA059FC4}" type="datetimeFigureOut">
               <a:rPr lang="en-US" smtClean="0"/>
-              <a:t>1/27/13</a:t>
+              <a:t>9/14/2026</a:t>
             </a:fld>
             <a:endParaRPr lang="en-US"/>
           </a:p>
@@ -1448,10 +1972,9 @@
           </a:lstStyle>
           <a:p>
             <a:r>
-              <a:rPr lang="en-US" smtClean="0"/>
+              <a:rPr lang="en-US"/>
               <a:t>Click to edit Master title style</a:t>
             </a:r>
-            <a:endParaRPr lang="en-US"/>
           </a:p>
         </p:txBody>
       </p:sp>
@@ -1514,7 +2037,7 @@
           <a:p>
             <a:pPr lvl="0"/>
             <a:r>
-              <a:rPr lang="en-US" smtClean="0"/>
+              <a:rPr lang="en-US"/>
               <a:t>Click to edit Master text styles</a:t>
             </a:r>
           </a:p>
@@ -1570,38 +2093,37 @@
           <a:p>
             <a:pPr lvl="0"/>
             <a:r>
-              <a:rPr lang="en-US" smtClean="0"/>
+              <a:rPr lang="en-US"/>
               <a:t>Click to edit Master text styles</a:t>
             </a:r>
           </a:p>
           <a:p>
             <a:pPr lvl="1"/>
             <a:r>
-              <a:rPr lang="en-US" smtClean="0"/>
+              <a:rPr lang="en-US"/>
               <a:t>Second level</a:t>
             </a:r>
           </a:p>
           <a:p>
             <a:pPr lvl="2"/>
             <a:r>
-              <a:rPr lang="en-US" smtClean="0"/>
+              <a:rPr lang="en-US"/>
               <a:t>Third level</a:t>
             </a:r>
           </a:p>
           <a:p>
             <a:pPr lvl="3"/>
             <a:r>
-              <a:rPr lang="en-US" smtClean="0"/>
+              <a:rPr lang="en-US"/>
               <a:t>Fourth level</a:t>
             </a:r>
           </a:p>
           <a:p>
             <a:pPr lvl="4"/>
             <a:r>
-              <a:rPr lang="en-US" smtClean="0"/>
+              <a:rPr lang="en-US"/>
               <a:t>Fifth level</a:t>
             </a:r>
-            <a:endParaRPr lang="en-US"/>
           </a:p>
         </p:txBody>
       </p:sp>
@@ -1664,7 +2186,7 @@
           <a:p>
             <a:pPr lvl="0"/>
             <a:r>
-              <a:rPr lang="en-US" smtClean="0"/>
+              <a:rPr lang="en-US"/>
               <a:t>Click to edit Master text styles</a:t>
             </a:r>
           </a:p>
@@ -1720,38 +2242,37 @@
           <a:p>
             <a:pPr lvl="0"/>
             <a:r>
-              <a:rPr lang="en-US" smtClean="0"/>
+              <a:rPr lang="en-US"/>
               <a:t>Click to edit Master text styles</a:t>
             </a:r>
           </a:p>
           <a:p>
             <a:pPr lvl="1"/>
             <a:r>
-              <a:rPr lang="en-US" smtClean="0"/>
+              <a:rPr lang="en-US"/>
               <a:t>Second level</a:t>
             </a:r>
           </a:p>
           <a:p>
             <a:pPr lvl="2"/>
             <a:r>
-              <a:rPr lang="en-US" smtClean="0"/>
+              <a:rPr lang="en-US"/>
               <a:t>Third level</a:t>
             </a:r>
           </a:p>
           <a:p>
             <a:pPr lvl="3"/>
             <a:r>
-              <a:rPr lang="en-US" smtClean="0"/>
+              <a:rPr lang="en-US"/>
               <a:t>Fourth level</a:t>
             </a:r>
           </a:p>
           <a:p>
             <a:pPr lvl="4"/>
             <a:r>
-              <a:rPr lang="en-US" smtClean="0"/>
+              <a:rPr lang="en-US"/>
               <a:t>Fifth level</a:t>
             </a:r>
-            <a:endParaRPr lang="en-US"/>
           </a:p>
         </p:txBody>
       </p:sp>
@@ -1772,7 +2293,7 @@
           <a:p>
             <a:fld id="{5BCAD085-E8A6-8845-BD4E-CB4CCA059FC4}" type="datetimeFigureOut">
               <a:rPr lang="en-US" smtClean="0"/>
-              <a:t>1/27/13</a:t>
+              <a:t>9/14/2026</a:t>
             </a:fld>
             <a:endParaRPr lang="en-US"/>
           </a:p>
@@ -1866,10 +2387,9 @@
           <a:lstStyle/>
           <a:p>
             <a:r>
-              <a:rPr lang="en-US" smtClean="0"/>
+              <a:rPr lang="en-US"/>
               <a:t>Click to edit Master title style</a:t>
             </a:r>
-            <a:endParaRPr lang="en-US"/>
           </a:p>
         </p:txBody>
       </p:sp>
@@ -1890,7 +2410,7 @@
           <a:p>
             <a:fld id="{5BCAD085-E8A6-8845-BD4E-CB4CCA059FC4}" type="datetimeFigureOut">
               <a:rPr lang="en-US" smtClean="0"/>
-              <a:t>1/27/13</a:t>
+              <a:t>9/14/2026</a:t>
             </a:fld>
             <a:endParaRPr lang="en-US"/>
           </a:p>
@@ -1985,7 +2505,7 @@
           <a:p>
             <a:fld id="{5BCAD085-E8A6-8845-BD4E-CB4CCA059FC4}" type="datetimeFigureOut">
               <a:rPr lang="en-US" smtClean="0"/>
-              <a:t>1/27/13</a:t>
+              <a:t>9/14/2026</a:t>
             </a:fld>
             <a:endParaRPr lang="en-US"/>
           </a:p>
@@ -2088,10 +2608,9 @@
           </a:lstStyle>
           <a:p>
             <a:r>
-              <a:rPr lang="en-US" smtClean="0"/>
+              <a:rPr lang="en-US"/>
               <a:t>Click to edit Master title style</a:t>
             </a:r>
-            <a:endParaRPr lang="en-US"/>
           </a:p>
         </p:txBody>
       </p:sp>
@@ -2145,38 +2664,37 @@
           <a:p>
             <a:pPr lvl="0"/>
             <a:r>
-              <a:rPr lang="en-US" smtClean="0"/>
+              <a:rPr lang="en-US"/>
               <a:t>Click to edit Master text styles</a:t>
             </a:r>
           </a:p>
           <a:p>
             <a:pPr lvl="1"/>
             <a:r>
-              <a:rPr lang="en-US" smtClean="0"/>
+              <a:rPr lang="en-US"/>
               <a:t>Second level</a:t>
             </a:r>
           </a:p>
           <a:p>
             <a:pPr lvl="2"/>
             <a:r>
-              <a:rPr lang="en-US" smtClean="0"/>
+              <a:rPr lang="en-US"/>
               <a:t>Third level</a:t>
             </a:r>
           </a:p>
           <a:p>
             <a:pPr lvl="3"/>
             <a:r>
-              <a:rPr lang="en-US" smtClean="0"/>
+              <a:rPr lang="en-US"/>
               <a:t>Fourth level</a:t>
             </a:r>
           </a:p>
           <a:p>
             <a:pPr lvl="4"/>
             <a:r>
-              <a:rPr lang="en-US" smtClean="0"/>
+              <a:rPr lang="en-US"/>
               <a:t>Fifth level</a:t>
             </a:r>
-            <a:endParaRPr lang="en-US"/>
           </a:p>
         </p:txBody>
       </p:sp>
@@ -2239,7 +2757,7 @@
           <a:p>
             <a:pPr lvl="0"/>
             <a:r>
-              <a:rPr lang="en-US" smtClean="0"/>
+              <a:rPr lang="en-US"/>
               <a:t>Click to edit Master text styles</a:t>
             </a:r>
           </a:p>
@@ -2262,7 +2780,7 @@
           <a:p>
             <a:fld id="{5BCAD085-E8A6-8845-BD4E-CB4CCA059FC4}" type="datetimeFigureOut">
               <a:rPr lang="en-US" smtClean="0"/>
-              <a:t>1/27/13</a:t>
+              <a:t>9/14/2026</a:t>
             </a:fld>
             <a:endParaRPr lang="en-US"/>
           </a:p>
@@ -2365,10 +2883,9 @@
           </a:lstStyle>
           <a:p>
             <a:r>
-              <a:rPr lang="en-US" smtClean="0"/>
+              <a:rPr lang="en-US"/>
               <a:t>Click to edit Master title style</a:t>
             </a:r>
-            <a:endParaRPr lang="en-US"/>
           </a:p>
         </p:txBody>
       </p:sp>
@@ -2492,7 +3009,7 @@
           <a:p>
             <a:pPr lvl="0"/>
             <a:r>
-              <a:rPr lang="en-US" smtClean="0"/>
+              <a:rPr lang="en-US"/>
               <a:t>Click to edit Master text styles</a:t>
             </a:r>
           </a:p>
@@ -2515,7 +3032,7 @@
           <a:p>
             <a:fld id="{5BCAD085-E8A6-8845-BD4E-CB4CCA059FC4}" type="datetimeFigureOut">
               <a:rPr lang="en-US" smtClean="0"/>
-              <a:t>1/27/13</a:t>
+              <a:t>9/14/2026</a:t>
             </a:fld>
             <a:endParaRPr lang="en-US"/>
           </a:p>
@@ -2624,10 +3141,9 @@
           <a:lstStyle/>
           <a:p>
             <a:r>
-              <a:rPr lang="en-US" smtClean="0"/>
+              <a:rPr lang="en-US"/>
               <a:t>Click to edit Master title style</a:t>
             </a:r>
-            <a:endParaRPr lang="en-US"/>
           </a:p>
         </p:txBody>
       </p:sp>
@@ -2658,38 +3174,37 @@
           <a:p>
             <a:pPr lvl="0"/>
             <a:r>
-              <a:rPr lang="en-US" smtClean="0"/>
+              <a:rPr lang="en-US"/>
               <a:t>Click to edit Master text styles</a:t>
             </a:r>
           </a:p>
           <a:p>
             <a:pPr lvl="1"/>
             <a:r>
-              <a:rPr lang="en-US" smtClean="0"/>
+              <a:rPr lang="en-US"/>
               <a:t>Second level</a:t>
             </a:r>
           </a:p>
           <a:p>
             <a:pPr lvl="2"/>
             <a:r>
-              <a:rPr lang="en-US" smtClean="0"/>
+              <a:rPr lang="en-US"/>
               <a:t>Third level</a:t>
             </a:r>
           </a:p>
           <a:p>
             <a:pPr lvl="3"/>
             <a:r>
-              <a:rPr lang="en-US" smtClean="0"/>
+              <a:rPr lang="en-US"/>
               <a:t>Fourth level</a:t>
             </a:r>
           </a:p>
           <a:p>
             <a:pPr lvl="4"/>
             <a:r>
-              <a:rPr lang="en-US" smtClean="0"/>
+              <a:rPr lang="en-US"/>
               <a:t>Fifth level</a:t>
             </a:r>
-            <a:endParaRPr lang="en-US"/>
           </a:p>
         </p:txBody>
       </p:sp>
@@ -2728,7 +3243,7 @@
           <a:p>
             <a:fld id="{5BCAD085-E8A6-8845-BD4E-CB4CCA059FC4}" type="datetimeFigureOut">
               <a:rPr lang="en-US" smtClean="0"/>
-              <a:t>1/27/13</a:t>
+              <a:t>9/14/2026</a:t>
             </a:fld>
             <a:endParaRPr lang="en-US"/>
           </a:p>
@@ -3087,7 +3602,7 @@
 </file>
 
 <file path=ppt/slides/slide1.xml><?xml version="1.0" encoding="utf-8"?>
-<p:sld xmlns:a="http://schemas.openxmlformats.org/drawingml/2006/main" xmlns:p="http://schemas.openxmlformats.org/presentationml/2006/main" xmlns:r="http://schemas.openxmlformats.org/officeDocument/2006/relationships">
+<p:sld xmlns:a="http://schemas.openxmlformats.org/drawingml/2006/main" xmlns:r="http://schemas.openxmlformats.org/officeDocument/2006/relationships" xmlns:p="http://schemas.openxmlformats.org/presentationml/2006/main">
   <p:cSld>
     <p:spTree>
       <p:nvGrpSpPr>
@@ -3095,7 +3610,14 @@
         <p:cNvGrpSpPr/>
         <p:nvPr/>
       </p:nvGrpSpPr>
-      <p:grpSpPr/>
+      <p:grpSpPr>
+        <a:xfrm>
+          <a:off x="0" y="0"/>
+          <a:ext cx="0" cy="0"/>
+          <a:chOff x="0" y="0"/>
+          <a:chExt cx="0" cy="0"/>
+        </a:xfrm>
+      </p:grpSpPr>
       <p:pic>
         <p:nvPicPr>
           <p:cNvPr id="2" name="Picture 1" descr="slide-bg-campus-plain.png"/>
@@ -3122,46 +3644,6 @@
       </p:pic>
       <p:sp>
         <p:nvSpPr>
-          <p:cNvPr id="3" name="TextBox 2"/>
-          <p:cNvSpPr txBox="1"/>
-          <p:nvPr/>
-        </p:nvSpPr>
-        <p:spPr>
-          <a:xfrm>
-            <a:off x="640080" y="1737360"/>
-            <a:ext cx="10058400" cy="320040"/>
-          </a:xfrm>
-          <a:prstGeom prst="rect">
-            <a:avLst/>
-          </a:prstGeom>
-          <a:noFill/>
-        </p:spPr>
-        <p:txBody>
-          <a:bodyPr wrap="square">
-            <a:spAutoFit/>
-          </a:bodyPr>
-          <a:lstStyle/>
-          <a:p>
-            <a:pPr algn="l">
-              <a:spcAft>
-                <a:spcPts val="600"/>
-              </a:spcAft>
-            </a:pPr>
-            <a:r>
-              <a:rPr sz="1500" b="1">
-                <a:solidFill>
-                  <a:srgbClr val="1F8A80"/>
-                </a:solidFill>
-                <a:latin typeface="Microsoft JhengHei"/>
-                <a:ea typeface="Microsoft JhengHei"/>
-              </a:rPr>
-              <a:t>Campus AI</a:t>
-            </a:r>
-          </a:p>
-        </p:txBody>
-      </p:sp>
-      <p:sp>
-        <p:nvSpPr>
           <p:cNvPr id="4" name="TextBox 3"/>
           <p:cNvSpPr txBox="1"/>
           <p:nvPr/>
@@ -3209,7 +3691,7 @@
         <p:spPr>
           <a:xfrm>
             <a:off x="640080" y="3108960"/>
-            <a:ext cx="10515600" cy="914400"/>
+            <a:ext cx="10515600" cy="687368"/>
           </a:xfrm>
           <a:prstGeom prst="rect">
             <a:avLst/>
@@ -3228,14 +3710,64 @@
               </a:spcAft>
             </a:pPr>
             <a:r>
-              <a:rPr sz="1600" b="0">
+              <a:rPr lang="zh-TW" altLang="en-US" sz="1600" b="0" dirty="0">
                 <a:solidFill>
                   <a:srgbClr val="5A656B"/>
                 </a:solidFill>
                 <a:latin typeface="Microsoft JhengHei"/>
                 <a:ea typeface="Microsoft JhengHei"/>
               </a:rPr>
-              <a:t>職責分離：Client 管對話與流程；MCP Server 只做知識檢索。</a:t>
+              <a:t>採用明確職責分離，</a:t>
+            </a:r>
+            <a:r>
+              <a:rPr sz="1600" b="0" dirty="0">
+                <a:solidFill>
+                  <a:srgbClr val="5A656B"/>
+                </a:solidFill>
+                <a:latin typeface="Microsoft JhengHei"/>
+                <a:ea typeface="Microsoft JhengHei"/>
+              </a:rPr>
+              <a:t>Client </a:t>
+            </a:r>
+            <a:r>
+              <a:rPr sz="1600" b="0" dirty="0" err="1">
+                <a:solidFill>
+                  <a:srgbClr val="5A656B"/>
+                </a:solidFill>
+                <a:latin typeface="Microsoft JhengHei"/>
+                <a:ea typeface="Microsoft JhengHei"/>
+              </a:rPr>
+              <a:t>管對話與流程；MCP</a:t>
+            </a:r>
+            <a:r>
+              <a:rPr sz="1600" b="0" dirty="0">
+                <a:solidFill>
+                  <a:srgbClr val="5A656B"/>
+                </a:solidFill>
+                <a:latin typeface="Microsoft JhengHei"/>
+                <a:ea typeface="Microsoft JhengHei"/>
+              </a:rPr>
+              <a:t> Server </a:t>
+            </a:r>
+            <a:r>
+              <a:rPr sz="1600" b="0" dirty="0" err="1">
+                <a:solidFill>
+                  <a:srgbClr val="5A656B"/>
+                </a:solidFill>
+                <a:latin typeface="Microsoft JhengHei"/>
+                <a:ea typeface="Microsoft JhengHei"/>
+              </a:rPr>
+              <a:t>只做知識檢索</a:t>
+            </a:r>
+            <a:r>
+              <a:rPr sz="1600" b="0" dirty="0">
+                <a:solidFill>
+                  <a:srgbClr val="5A656B"/>
+                </a:solidFill>
+                <a:latin typeface="Microsoft JhengHei"/>
+                <a:ea typeface="Microsoft JhengHei"/>
+              </a:rPr>
+              <a:t>。</a:t>
             </a:r>
           </a:p>
           <a:p>
@@ -3245,14 +3777,124 @@
               </a:spcAft>
             </a:pPr>
             <a:r>
-              <a:rPr sz="1600" b="0">
+              <a:rPr sz="1600" b="0" dirty="0" err="1">
                 <a:solidFill>
                   <a:srgbClr val="5A656B"/>
                 </a:solidFill>
                 <a:latin typeface="Microsoft JhengHei"/>
                 <a:ea typeface="Microsoft JhengHei"/>
               </a:rPr>
-              <a:t>校務資料在 SQL Server；規章問答走 rag_retrieve；回覆由 Gemini 整理。</a:t>
+              <a:t>校務資料在</a:t>
+            </a:r>
+            <a:r>
+              <a:rPr sz="1600" b="0" dirty="0">
+                <a:solidFill>
+                  <a:srgbClr val="5A656B"/>
+                </a:solidFill>
+                <a:latin typeface="Microsoft JhengHei"/>
+                <a:ea typeface="Microsoft JhengHei"/>
+              </a:rPr>
+              <a:t> SQL Server</a:t>
+            </a:r>
+            <a:r>
+              <a:rPr lang="zh-TW" altLang="en-US" sz="1600" b="0" dirty="0">
+                <a:solidFill>
+                  <a:srgbClr val="5A656B"/>
+                </a:solidFill>
+                <a:latin typeface="Microsoft JhengHei"/>
+                <a:ea typeface="Microsoft JhengHei"/>
+              </a:rPr>
+              <a:t>，</a:t>
+            </a:r>
+            <a:r>
+              <a:rPr sz="1600" b="0" dirty="0" err="1">
+                <a:solidFill>
+                  <a:srgbClr val="5A656B"/>
+                </a:solidFill>
+                <a:latin typeface="Microsoft JhengHei"/>
+                <a:ea typeface="Microsoft JhengHei"/>
+              </a:rPr>
+              <a:t>規章問答走</a:t>
+            </a:r>
+            <a:r>
+              <a:rPr sz="1600" b="0" dirty="0">
+                <a:solidFill>
+                  <a:srgbClr val="5A656B"/>
+                </a:solidFill>
+                <a:latin typeface="Microsoft JhengHei"/>
+                <a:ea typeface="Microsoft JhengHei"/>
+              </a:rPr>
+              <a:t> </a:t>
+            </a:r>
+            <a:r>
+              <a:rPr sz="1600" b="0" dirty="0" err="1">
+                <a:solidFill>
+                  <a:srgbClr val="5A656B"/>
+                </a:solidFill>
+                <a:latin typeface="Microsoft JhengHei"/>
+                <a:ea typeface="Microsoft JhengHei"/>
+              </a:rPr>
+              <a:t>rag_retrieve</a:t>
+            </a:r>
+            <a:r>
+              <a:rPr lang="zh-TW" altLang="en-US" sz="1600" b="0" dirty="0">
+                <a:solidFill>
+                  <a:srgbClr val="5A656B"/>
+                </a:solidFill>
+                <a:latin typeface="Microsoft JhengHei"/>
+                <a:ea typeface="Microsoft JhengHei"/>
+              </a:rPr>
+              <a:t>，</a:t>
+            </a:r>
+            <a:r>
+              <a:rPr sz="1600" b="0" dirty="0" err="1">
+                <a:solidFill>
+                  <a:srgbClr val="5A656B"/>
+                </a:solidFill>
+                <a:latin typeface="Microsoft JhengHei"/>
+                <a:ea typeface="Microsoft JhengHei"/>
+              </a:rPr>
+              <a:t>回覆</a:t>
+            </a:r>
+            <a:r>
+              <a:rPr lang="zh-TW" altLang="en-US" sz="1600" b="0" dirty="0">
+                <a:solidFill>
+                  <a:srgbClr val="5A656B"/>
+                </a:solidFill>
+                <a:latin typeface="Microsoft JhengHei"/>
+                <a:ea typeface="Microsoft JhengHei"/>
+              </a:rPr>
+              <a:t>交</a:t>
+            </a:r>
+            <a:r>
+              <a:rPr sz="1600" b="0" dirty="0">
+                <a:solidFill>
+                  <a:srgbClr val="5A656B"/>
+                </a:solidFill>
+                <a:latin typeface="Microsoft JhengHei"/>
+                <a:ea typeface="Microsoft JhengHei"/>
+              </a:rPr>
+              <a:t>由 Gemini </a:t>
+            </a:r>
+            <a:r>
+              <a:rPr sz="1600" b="0" dirty="0" err="1">
+                <a:solidFill>
+                  <a:srgbClr val="5A656B"/>
+                </a:solidFill>
+                <a:latin typeface="Microsoft JhengHei"/>
+                <a:ea typeface="Microsoft JhengHei"/>
+              </a:rPr>
+              <a:t>整理</a:t>
+            </a:r>
+            <a:r>
+              <a:rPr sz="1600" b="0" dirty="0">
+                <a:solidFill>
+                  <a:srgbClr val="5A656B"/>
+                </a:solidFill>
+                <a:latin typeface="Microsoft JhengHei"/>
+                <a:ea typeface="Microsoft JhengHei"/>
+              </a:rPr>
+              <a:t>。</a:t>
             </a:r>
           </a:p>
         </p:txBody>
@@ -3299,6 +3941,7 @@
           <a:lstStyle/>
           <a:p>
             <a:pPr algn="ctr"/>
+            <a:endParaRPr/>
           </a:p>
         </p:txBody>
       </p:sp>
@@ -3384,6 +4027,7 @@
           <a:lstStyle/>
           <a:p>
             <a:pPr algn="ctr"/>
+            <a:endParaRPr/>
           </a:p>
         </p:txBody>
       </p:sp>
@@ -3469,6 +4113,7 @@
           <a:lstStyle/>
           <a:p>
             <a:pPr algn="ctr"/>
+            <a:endParaRPr/>
           </a:p>
         </p:txBody>
       </p:sp>
@@ -3554,6 +4199,7 @@
           <a:lstStyle/>
           <a:p>
             <a:pPr algn="ctr"/>
+            <a:endParaRPr/>
           </a:p>
         </p:txBody>
       </p:sp>
@@ -3639,6 +4285,7 @@
           <a:lstStyle/>
           <a:p>
             <a:pPr algn="ctr"/>
+            <a:endParaRPr/>
           </a:p>
         </p:txBody>
       </p:sp>
@@ -3724,6 +4371,7 @@
           <a:lstStyle/>
           <a:p>
             <a:pPr algn="ctr"/>
+            <a:endParaRPr/>
           </a:p>
         </p:txBody>
       </p:sp>
@@ -3816,7 +4464,7 @@
 </file>
 
 <file path=ppt/slides/slide2.xml><?xml version="1.0" encoding="utf-8"?>
-<p:sld xmlns:a="http://schemas.openxmlformats.org/drawingml/2006/main" xmlns:p="http://schemas.openxmlformats.org/presentationml/2006/main" xmlns:r="http://schemas.openxmlformats.org/officeDocument/2006/relationships">
+<p:sld xmlns:a="http://schemas.openxmlformats.org/drawingml/2006/main" xmlns:r="http://schemas.openxmlformats.org/officeDocument/2006/relationships" xmlns:p="http://schemas.openxmlformats.org/presentationml/2006/main">
   <p:cSld>
     <p:spTree>
       <p:nvGrpSpPr>
@@ -3824,7 +4472,14 @@
         <p:cNvGrpSpPr/>
         <p:nvPr/>
       </p:nvGrpSpPr>
-      <p:grpSpPr/>
+      <p:grpSpPr>
+        <a:xfrm>
+          <a:off x="0" y="0"/>
+          <a:ext cx="0" cy="0"/>
+          <a:chOff x="0" y="0"/>
+          <a:chExt cx="0" cy="0"/>
+        </a:xfrm>
+      </p:grpSpPr>
       <p:pic>
         <p:nvPicPr>
           <p:cNvPr id="2" name="Picture 1" descr="slide-bg-campus-plain.png"/>
@@ -3834,7 +4489,7 @@
           <p:nvPr/>
         </p:nvPicPr>
         <p:blipFill>
-          <a:blip r:embed="rId2"/>
+          <a:blip r:embed="rId3"/>
           <a:stretch>
             <a:fillRect/>
           </a:stretch>
@@ -3849,46 +4504,6 @@
           </a:prstGeom>
         </p:spPr>
       </p:pic>
-      <p:sp>
-        <p:nvSpPr>
-          <p:cNvPr id="3" name="TextBox 2"/>
-          <p:cNvSpPr txBox="1"/>
-          <p:nvPr/>
-        </p:nvSpPr>
-        <p:spPr>
-          <a:xfrm>
-            <a:off x="640080" y="320040"/>
-            <a:ext cx="9144000" cy="256032"/>
-          </a:xfrm>
-          <a:prstGeom prst="rect">
-            <a:avLst/>
-          </a:prstGeom>
-          <a:noFill/>
-        </p:spPr>
-        <p:txBody>
-          <a:bodyPr wrap="square">
-            <a:spAutoFit/>
-          </a:bodyPr>
-          <a:lstStyle/>
-          <a:p>
-            <a:pPr algn="l">
-              <a:spcAft>
-                <a:spcPts val="600"/>
-              </a:spcAft>
-            </a:pPr>
-            <a:r>
-              <a:rPr sz="1200" b="1">
-                <a:solidFill>
-                  <a:srgbClr val="1F8A80"/>
-                </a:solidFill>
-                <a:latin typeface="Microsoft JhengHei"/>
-                <a:ea typeface="Microsoft JhengHei"/>
-              </a:rPr>
-              <a:t>Campus AI</a:t>
-            </a:r>
-          </a:p>
-        </p:txBody>
-      </p:sp>
       <p:sp>
         <p:nvSpPr>
           <p:cNvPr id="4" name="TextBox 3"/>
@@ -4051,6 +4666,7 @@
           <a:lstStyle/>
           <a:p>
             <a:pPr algn="ctr"/>
+            <a:endParaRPr/>
           </a:p>
         </p:txBody>
       </p:sp>
@@ -4103,7 +4719,7 @@
         <p:spPr>
           <a:xfrm>
             <a:off x="822959" y="2240280"/>
-            <a:ext cx="3139440" cy="731520"/>
+            <a:ext cx="3139440" cy="292388"/>
           </a:xfrm>
           <a:prstGeom prst="rect">
             <a:avLst/>
@@ -4122,15 +4738,52 @@
               </a:spcAft>
             </a:pPr>
             <a:r>
-              <a:rPr sz="1300" b="0">
+              <a:rPr sz="1300" b="0" dirty="0" err="1">
                 <a:solidFill>
                   <a:srgbClr val="5A656B"/>
                 </a:solidFill>
                 <a:latin typeface="Microsoft JhengHei"/>
                 <a:ea typeface="Microsoft JhengHei"/>
               </a:rPr>
-              <a:t>規格：只有一個功能——RAG 檢索</a:t>
-            </a:r>
+              <a:t>只有RAG</a:t>
+            </a:r>
+            <a:r>
+              <a:rPr sz="1300" b="0" dirty="0">
+                <a:solidFill>
+                  <a:srgbClr val="5A656B"/>
+                </a:solidFill>
+                <a:latin typeface="Microsoft JhengHei"/>
+                <a:ea typeface="Microsoft JhengHei"/>
+              </a:rPr>
+              <a:t> </a:t>
+            </a:r>
+            <a:r>
+              <a:rPr sz="1300" b="0" dirty="0" err="1">
+                <a:solidFill>
+                  <a:srgbClr val="5A656B"/>
+                </a:solidFill>
+                <a:latin typeface="Microsoft JhengHei"/>
+                <a:ea typeface="Microsoft JhengHei"/>
+              </a:rPr>
+              <a:t>檢索</a:t>
+            </a:r>
+            <a:r>
+              <a:rPr lang="zh-TW" altLang="en-US" sz="1300" b="0" dirty="0">
+                <a:solidFill>
+                  <a:srgbClr val="5A656B"/>
+                </a:solidFill>
+                <a:latin typeface="Microsoft JhengHei"/>
+                <a:ea typeface="Microsoft JhengHei"/>
+              </a:rPr>
+              <a:t>功能。</a:t>
+            </a:r>
+            <a:endParaRPr sz="1300" b="0" dirty="0">
+              <a:solidFill>
+                <a:srgbClr val="5A656B"/>
+              </a:solidFill>
+              <a:latin typeface="Microsoft JhengHei"/>
+              <a:ea typeface="Microsoft JhengHei"/>
+            </a:endParaRPr>
           </a:p>
         </p:txBody>
       </p:sp>
@@ -4202,14 +4855,64 @@
               </a:spcAft>
             </a:pPr>
             <a:r>
-              <a:rPr sz="1300" b="0">
+              <a:rPr sz="1300" b="0" dirty="0" err="1">
                 <a:solidFill>
                   <a:srgbClr val="1C2428"/>
                 </a:solidFill>
                 <a:latin typeface="Microsoft JhengHei"/>
                 <a:ea typeface="Microsoft JhengHei"/>
               </a:rPr>
-              <a:t>僅開放單一端點，獨立於對話機制外；針對 campus-docs.json 做語意／關鍵字檢索。</a:t>
+              <a:t>僅開放單一端點，獨立於對話機制外；針對</a:t>
+            </a:r>
+            <a:r>
+              <a:rPr sz="1300" b="0" dirty="0">
+                <a:solidFill>
+                  <a:srgbClr val="1C2428"/>
+                </a:solidFill>
+                <a:latin typeface="Microsoft JhengHei"/>
+                <a:ea typeface="Microsoft JhengHei"/>
+              </a:rPr>
+              <a:t> campus-</a:t>
+            </a:r>
+            <a:r>
+              <a:rPr sz="1300" b="0" dirty="0" err="1">
+                <a:solidFill>
+                  <a:srgbClr val="1C2428"/>
+                </a:solidFill>
+                <a:latin typeface="Microsoft JhengHei"/>
+                <a:ea typeface="Microsoft JhengHei"/>
+              </a:rPr>
+              <a:t>docs.json</a:t>
+            </a:r>
+            <a:r>
+              <a:rPr sz="1300" b="0" dirty="0">
+                <a:solidFill>
+                  <a:srgbClr val="1C2428"/>
+                </a:solidFill>
+                <a:latin typeface="Microsoft JhengHei"/>
+                <a:ea typeface="Microsoft JhengHei"/>
+              </a:rPr>
+              <a:t> </a:t>
+            </a:r>
+            <a:r>
+              <a:rPr sz="1300" b="0" dirty="0" err="1">
+                <a:solidFill>
+                  <a:srgbClr val="1C2428"/>
+                </a:solidFill>
+                <a:latin typeface="Microsoft JhengHei"/>
+                <a:ea typeface="Microsoft JhengHei"/>
+              </a:rPr>
+              <a:t>做語意／關鍵字檢索</a:t>
+            </a:r>
+            <a:r>
+              <a:rPr sz="1300" b="0" dirty="0">
+                <a:solidFill>
+                  <a:srgbClr val="1C2428"/>
+                </a:solidFill>
+                <a:latin typeface="Microsoft JhengHei"/>
+                <a:ea typeface="Microsoft JhengHei"/>
+              </a:rPr>
+              <a:t>。</a:t>
             </a:r>
           </a:p>
         </p:txBody>
@@ -4256,6 +4959,7 @@
           <a:lstStyle/>
           <a:p>
             <a:pPr algn="ctr"/>
+            <a:endParaRPr/>
           </a:p>
         </p:txBody>
       </p:sp>
@@ -4308,7 +5012,7 @@
         <p:spPr>
           <a:xfrm>
             <a:off x="4511040" y="2240280"/>
-            <a:ext cx="3139440" cy="731520"/>
+            <a:ext cx="3139440" cy="292388"/>
           </a:xfrm>
           <a:prstGeom prst="rect">
             <a:avLst/>
@@ -4327,15 +5031,32 @@
               </a:spcAft>
             </a:pPr>
             <a:r>
-              <a:rPr sz="1300" b="0">
+              <a:rPr sz="1300" b="0" dirty="0" err="1">
                 <a:solidFill>
                   <a:srgbClr val="5A656B"/>
                 </a:solidFill>
                 <a:latin typeface="Microsoft JhengHei"/>
                 <a:ea typeface="Microsoft JhengHei"/>
               </a:rPr>
-              <a:t>規格：負責使用者對話管理</a:t>
-            </a:r>
+              <a:t>負責使用者對話管理</a:t>
+            </a:r>
+            <a:r>
+              <a:rPr lang="zh-TW" altLang="en-US" sz="1300" b="0" dirty="0">
+                <a:solidFill>
+                  <a:srgbClr val="5A656B"/>
+                </a:solidFill>
+                <a:latin typeface="Microsoft JhengHei"/>
+                <a:ea typeface="Microsoft JhengHei"/>
+              </a:rPr>
+              <a:t>。</a:t>
+            </a:r>
+            <a:endParaRPr sz="1300" b="0" dirty="0">
+              <a:solidFill>
+                <a:srgbClr val="5A656B"/>
+              </a:solidFill>
+              <a:latin typeface="Microsoft JhengHei"/>
+              <a:ea typeface="Microsoft JhengHei"/>
+            </a:endParaRPr>
           </a:p>
         </p:txBody>
       </p:sp>
@@ -4461,6 +5182,7 @@
           <a:lstStyle/>
           <a:p>
             <a:pPr algn="ctr"/>
+            <a:endParaRPr/>
           </a:p>
         </p:txBody>
       </p:sp>
@@ -4506,154 +5228,124 @@
       </p:sp>
       <p:sp>
         <p:nvSpPr>
-          <p:cNvPr id="19" name="TextBox 18"/>
-          <p:cNvSpPr txBox="1"/>
-          <p:nvPr/>
-        </p:nvSpPr>
-        <p:spPr>
-          <a:xfrm>
-            <a:off x="8199119" y="2240280"/>
-            <a:ext cx="3139440" cy="731520"/>
-          </a:xfrm>
-          <a:prstGeom prst="rect">
-            <a:avLst/>
-          </a:prstGeom>
-          <a:noFill/>
-        </p:spPr>
-        <p:txBody>
-          <a:bodyPr wrap="square">
-            <a:spAutoFit/>
-          </a:bodyPr>
-          <a:lstStyle/>
-          <a:p>
-            <a:pPr algn="l">
-              <a:spcAft>
-                <a:spcPts val="600"/>
-              </a:spcAft>
-            </a:pPr>
-            <a:r>
-              <a:rPr sz="1300" b="0">
-                <a:solidFill>
-                  <a:srgbClr val="5A656B"/>
-                </a:solidFill>
-                <a:latin typeface="Microsoft JhengHei"/>
-                <a:ea typeface="Microsoft JhengHei"/>
-              </a:rPr>
-              <a:t>本簡報：完整結構化架構解說</a:t>
-            </a:r>
-          </a:p>
-        </p:txBody>
-      </p:sp>
-      <p:sp>
-        <p:nvSpPr>
-          <p:cNvPr id="20" name="TextBox 19"/>
-          <p:cNvSpPr txBox="1"/>
-          <p:nvPr/>
-        </p:nvSpPr>
-        <p:spPr>
-          <a:xfrm>
-            <a:off x="8199119" y="3063240"/>
-            <a:ext cx="3139440" cy="640080"/>
-          </a:xfrm>
-          <a:prstGeom prst="rect">
-            <a:avLst/>
-          </a:prstGeom>
-          <a:noFill/>
-        </p:spPr>
-        <p:txBody>
-          <a:bodyPr wrap="square">
-            <a:spAutoFit/>
-          </a:bodyPr>
-          <a:lstStyle/>
-          <a:p>
-            <a:pPr algn="l">
-              <a:spcAft>
-                <a:spcPts val="600"/>
-              </a:spcAft>
-            </a:pPr>
-            <a:r>
-              <a:rPr sz="1400" b="1">
-                <a:solidFill>
-                  <a:srgbClr val="1F8A80"/>
-                </a:solidFill>
-                <a:latin typeface="Microsoft JhengHei"/>
-                <a:ea typeface="Microsoft JhengHei"/>
-              </a:rPr>
-              <a:t>熟悉實作語言</a:t>
-            </a:r>
-          </a:p>
-        </p:txBody>
-      </p:sp>
-      <p:sp>
-        <p:nvSpPr>
           <p:cNvPr id="21" name="TextBox 20"/>
           <p:cNvSpPr txBox="1"/>
           <p:nvPr/>
         </p:nvSpPr>
         <p:spPr>
           <a:xfrm>
-            <a:off x="8199119" y="3840480"/>
-            <a:ext cx="3139440" cy="2011680"/>
-          </a:xfrm>
-          <a:prstGeom prst="rect">
-            <a:avLst/>
-          </a:prstGeom>
-          <a:noFill/>
-        </p:spPr>
-        <p:txBody>
-          <a:bodyPr wrap="square">
-            <a:spAutoFit/>
-          </a:bodyPr>
-          <a:lstStyle/>
-          <a:p>
-            <a:pPr algn="l">
+            <a:off x="8229601" y="2240280"/>
+            <a:ext cx="3139440" cy="1097736"/>
+          </a:xfrm>
+          <a:prstGeom prst="rect">
+            <a:avLst/>
+          </a:prstGeom>
+          <a:noFill/>
+        </p:spPr>
+        <p:txBody>
+          <a:bodyPr wrap="square">
+            <a:spAutoFit/>
+          </a:bodyPr>
+          <a:lstStyle/>
+          <a:p>
+            <a:pPr>
               <a:spcAft>
                 <a:spcPts val="800"/>
               </a:spcAft>
             </a:pPr>
             <a:r>
-              <a:rPr sz="1300" b="0">
+              <a:rPr sz="1300" b="0" dirty="0">
                 <a:solidFill>
                   <a:srgbClr val="1C2428"/>
                 </a:solidFill>
                 <a:latin typeface="Microsoft JhengHei"/>
                 <a:ea typeface="Microsoft JhengHei"/>
               </a:rPr>
-              <a:t>C#（ASP.NET Core／SSMS）</a:t>
-            </a:r>
-          </a:p>
-          <a:p>
-            <a:pPr algn="l">
+              <a:t>C#（ASP.NET </a:t>
+            </a:r>
+            <a:r>
+              <a:rPr sz="1300" b="0" dirty="0" err="1">
+                <a:solidFill>
+                  <a:srgbClr val="1C2428"/>
+                </a:solidFill>
+                <a:latin typeface="Microsoft JhengHei"/>
+                <a:ea typeface="Microsoft JhengHei"/>
+              </a:rPr>
+              <a:t>Core／SSMS</a:t>
+            </a:r>
+            <a:r>
+              <a:rPr sz="1300" b="0" dirty="0">
+                <a:solidFill>
+                  <a:srgbClr val="1C2428"/>
+                </a:solidFill>
+                <a:latin typeface="Microsoft JhengHei"/>
+                <a:ea typeface="Microsoft JhengHei"/>
+              </a:rPr>
+              <a:t>）</a:t>
+            </a:r>
+          </a:p>
+          <a:p>
+            <a:pPr>
               <a:spcAft>
                 <a:spcPts val="800"/>
               </a:spcAft>
             </a:pPr>
             <a:r>
-              <a:rPr sz="1300" b="0">
+              <a:rPr sz="1300" b="0" dirty="0" err="1">
                 <a:solidFill>
                   <a:srgbClr val="1C2428"/>
                 </a:solidFill>
                 <a:latin typeface="Microsoft JhengHei"/>
                 <a:ea typeface="Microsoft JhengHei"/>
               </a:rPr>
-              <a:t>TypeScript（React ＋ Vite）</a:t>
-            </a:r>
-          </a:p>
-          <a:p>
-            <a:pPr algn="l">
+              <a:t>TypeScript（React</a:t>
+            </a:r>
+            <a:r>
+              <a:rPr sz="1300" b="0" dirty="0">
+                <a:solidFill>
+                  <a:srgbClr val="1C2428"/>
+                </a:solidFill>
+                <a:latin typeface="Microsoft JhengHei"/>
+                <a:ea typeface="Microsoft JhengHei"/>
+              </a:rPr>
+              <a:t> ＋ Vite）</a:t>
+            </a:r>
+          </a:p>
+          <a:p>
+            <a:pPr>
               <a:spcAft>
                 <a:spcPts val="800"/>
               </a:spcAft>
             </a:pPr>
             <a:r>
-              <a:rPr sz="1300" b="0">
+              <a:rPr sz="1300" b="0" dirty="0">
                 <a:solidFill>
                   <a:srgbClr val="1C2428"/>
                 </a:solidFill>
                 <a:latin typeface="Microsoft JhengHei"/>
                 <a:ea typeface="Microsoft JhengHei"/>
               </a:rPr>
-              <a:t>MCP RAG Server：C#（mcp-rag-server）</a:t>
+              <a:t>MCP RAG </a:t>
+            </a:r>
+            <a:r>
+              <a:rPr sz="1300" b="0" dirty="0" err="1">
+                <a:solidFill>
+                  <a:srgbClr val="1C2428"/>
+                </a:solidFill>
+                <a:latin typeface="Microsoft JhengHei"/>
+                <a:ea typeface="Microsoft JhengHei"/>
+              </a:rPr>
+              <a:t>Server：C</a:t>
+            </a:r>
+            <a:r>
+              <a:rPr sz="1300" b="0" dirty="0">
+                <a:solidFill>
+                  <a:srgbClr val="1C2428"/>
+                </a:solidFill>
+                <a:latin typeface="Microsoft JhengHei"/>
+                <a:ea typeface="Microsoft JhengHei"/>
+              </a:rPr>
+              <a:t>#（mcp-rag-server）</a:t>
             </a:r>
           </a:p>
         </p:txBody>
@@ -4667,7 +5359,7 @@
 </file>
 
 <file path=ppt/slides/slide3.xml><?xml version="1.0" encoding="utf-8"?>
-<p:sld xmlns:a="http://schemas.openxmlformats.org/drawingml/2006/main" xmlns:p="http://schemas.openxmlformats.org/presentationml/2006/main" xmlns:r="http://schemas.openxmlformats.org/officeDocument/2006/relationships">
+<p:sld xmlns:a="http://schemas.openxmlformats.org/drawingml/2006/main" xmlns:r="http://schemas.openxmlformats.org/officeDocument/2006/relationships" xmlns:p="http://schemas.openxmlformats.org/presentationml/2006/main">
   <p:cSld>
     <p:spTree>
       <p:nvGrpSpPr>
@@ -4675,7 +5367,14 @@
         <p:cNvGrpSpPr/>
         <p:nvPr/>
       </p:nvGrpSpPr>
-      <p:grpSpPr/>
+      <p:grpSpPr>
+        <a:xfrm>
+          <a:off x="0" y="0"/>
+          <a:ext cx="0" cy="0"/>
+          <a:chOff x="0" y="0"/>
+          <a:chExt cx="0" cy="0"/>
+        </a:xfrm>
+      </p:grpSpPr>
       <p:pic>
         <p:nvPicPr>
           <p:cNvPr id="2" name="Picture 1" descr="slide-bg-campus-plain.png"/>
@@ -4700,46 +5399,6 @@
           </a:prstGeom>
         </p:spPr>
       </p:pic>
-      <p:sp>
-        <p:nvSpPr>
-          <p:cNvPr id="3" name="TextBox 2"/>
-          <p:cNvSpPr txBox="1"/>
-          <p:nvPr/>
-        </p:nvSpPr>
-        <p:spPr>
-          <a:xfrm>
-            <a:off x="640080" y="320040"/>
-            <a:ext cx="9144000" cy="256032"/>
-          </a:xfrm>
-          <a:prstGeom prst="rect">
-            <a:avLst/>
-          </a:prstGeom>
-          <a:noFill/>
-        </p:spPr>
-        <p:txBody>
-          <a:bodyPr wrap="square">
-            <a:spAutoFit/>
-          </a:bodyPr>
-          <a:lstStyle/>
-          <a:p>
-            <a:pPr algn="l">
-              <a:spcAft>
-                <a:spcPts val="600"/>
-              </a:spcAft>
-            </a:pPr>
-            <a:r>
-              <a:rPr sz="1200" b="1">
-                <a:solidFill>
-                  <a:srgbClr val="1F8A80"/>
-                </a:solidFill>
-                <a:latin typeface="Microsoft JhengHei"/>
-                <a:ea typeface="Microsoft JhengHei"/>
-              </a:rPr>
-              <a:t>Campus AI</a:t>
-            </a:r>
-          </a:p>
-        </p:txBody>
-      </p:sp>
       <p:sp>
         <p:nvSpPr>
           <p:cNvPr id="4" name="TextBox 3"/>
@@ -4902,6 +5561,7 @@
           <a:lstStyle/>
           <a:p>
             <a:pPr algn="ctr"/>
+            <a:endParaRPr/>
           </a:p>
         </p:txBody>
       </p:sp>
@@ -4987,6 +5647,7 @@
           <a:lstStyle/>
           <a:p>
             <a:pPr algn="ctr"/>
+            <a:endParaRPr/>
           </a:p>
         </p:txBody>
       </p:sp>
@@ -5038,7 +5699,7 @@
         </p:nvSpPr>
         <p:spPr>
           <a:xfrm>
-            <a:off x="731519" y="2514600"/>
+            <a:off x="731519" y="2928975"/>
             <a:ext cx="1554480" cy="1554479"/>
           </a:xfrm>
           <a:prstGeom prst="rect">
@@ -5152,6 +5813,7 @@
           <a:lstStyle/>
           <a:p>
             <a:pPr algn="ctr"/>
+            <a:endParaRPr/>
           </a:p>
         </p:txBody>
       </p:sp>
@@ -5203,7 +5865,7 @@
         </p:nvSpPr>
         <p:spPr>
           <a:xfrm>
-            <a:off x="2560320" y="2514600"/>
+            <a:off x="2651760" y="2924692"/>
             <a:ext cx="1554480" cy="1554479"/>
           </a:xfrm>
           <a:prstGeom prst="rect">
@@ -5223,7 +5885,7 @@
               </a:spcAft>
             </a:pPr>
             <a:r>
-              <a:rPr sz="1100" b="0">
+              <a:rPr sz="1100" b="0" dirty="0" err="1">
                 <a:solidFill>
                   <a:srgbClr val="1C2428"/>
                 </a:solidFill>
@@ -5232,6 +5894,13 @@
               </a:rPr>
               <a:t>主畫面、側欄、多對話、入口</a:t>
             </a:r>
+            <a:endParaRPr sz="1100" b="0" dirty="0">
+              <a:solidFill>
+                <a:srgbClr val="1C2428"/>
+              </a:solidFill>
+              <a:latin typeface="Microsoft JhengHei"/>
+              <a:ea typeface="Microsoft JhengHei"/>
+            </a:endParaRPr>
           </a:p>
         </p:txBody>
       </p:sp>
@@ -5317,6 +5986,7 @@
           <a:lstStyle/>
           <a:p>
             <a:pPr algn="ctr"/>
+            <a:endParaRPr/>
           </a:p>
         </p:txBody>
       </p:sp>
@@ -5368,7 +6038,7 @@
         </p:nvSpPr>
         <p:spPr>
           <a:xfrm>
-            <a:off x="4389120" y="2514600"/>
+            <a:off x="4389120" y="2926081"/>
             <a:ext cx="1554480" cy="1554479"/>
           </a:xfrm>
           <a:prstGeom prst="rect">
@@ -5388,14 +6058,24 @@
               </a:spcAft>
             </a:pPr>
             <a:r>
-              <a:rPr sz="1100" b="0">
+              <a:rPr sz="1100" b="0" dirty="0" err="1">
                 <a:solidFill>
                   <a:srgbClr val="1C2428"/>
                 </a:solidFill>
                 <a:latin typeface="Microsoft JhengHei"/>
                 <a:ea typeface="Microsoft JhengHei"/>
               </a:rPr>
-              <a:t>JWT、對話持久化、校務 API</a:t>
+              <a:t>JWT、對話持久化、校務</a:t>
+            </a:r>
+            <a:r>
+              <a:rPr sz="1100" b="0" dirty="0">
+                <a:solidFill>
+                  <a:srgbClr val="1C2428"/>
+                </a:solidFill>
+                <a:latin typeface="Microsoft JhengHei"/>
+                <a:ea typeface="Microsoft JhengHei"/>
+              </a:rPr>
+              <a:t> API</a:t>
             </a:r>
           </a:p>
         </p:txBody>
@@ -5482,6 +6162,7 @@
           <a:lstStyle/>
           <a:p>
             <a:pPr algn="ctr"/>
+            <a:endParaRPr/>
           </a:p>
         </p:txBody>
       </p:sp>
@@ -5533,7 +6214,7 @@
         </p:nvSpPr>
         <p:spPr>
           <a:xfrm>
-            <a:off x="6217920" y="2514600"/>
+            <a:off x="6217920" y="2926081"/>
             <a:ext cx="1554480" cy="1554479"/>
           </a:xfrm>
           <a:prstGeom prst="rect">
@@ -5553,15 +6234,42 @@
               </a:spcAft>
             </a:pPr>
             <a:r>
-              <a:rPr sz="1100" b="0">
+              <a:rPr sz="1100" b="0" dirty="0" err="1">
                 <a:solidFill>
                   <a:srgbClr val="1C2428"/>
                 </a:solidFill>
                 <a:latin typeface="Microsoft JhengHei"/>
                 <a:ea typeface="Microsoft JhengHei"/>
               </a:rPr>
-              <a:t>意圖判斷、Agent 調度</a:t>
-            </a:r>
+              <a:t>意圖判斷、Agent</a:t>
+            </a:r>
+            <a:r>
+              <a:rPr sz="1100" b="0" dirty="0">
+                <a:solidFill>
+                  <a:srgbClr val="1C2428"/>
+                </a:solidFill>
+                <a:latin typeface="Microsoft JhengHei"/>
+                <a:ea typeface="Microsoft JhengHei"/>
+              </a:rPr>
+              <a:t> </a:t>
+            </a:r>
+            <a:r>
+              <a:rPr sz="1100" b="0" dirty="0" err="1">
+                <a:solidFill>
+                  <a:srgbClr val="1C2428"/>
+                </a:solidFill>
+                <a:latin typeface="Microsoft JhengHei"/>
+                <a:ea typeface="Microsoft JhengHei"/>
+              </a:rPr>
+              <a:t>調度</a:t>
+            </a:r>
+            <a:endParaRPr sz="1100" b="0" dirty="0">
+              <a:solidFill>
+                <a:srgbClr val="1C2428"/>
+              </a:solidFill>
+              <a:latin typeface="Microsoft JhengHei"/>
+              <a:ea typeface="Microsoft JhengHei"/>
+            </a:endParaRPr>
           </a:p>
         </p:txBody>
       </p:sp>
@@ -5647,6 +6355,7 @@
           <a:lstStyle/>
           <a:p>
             <a:pPr algn="ctr"/>
+            <a:endParaRPr/>
           </a:p>
         </p:txBody>
       </p:sp>
@@ -5698,7 +6407,7 @@
         </p:nvSpPr>
         <p:spPr>
           <a:xfrm>
-            <a:off x="8046719" y="2514600"/>
+            <a:off x="8229598" y="2923303"/>
             <a:ext cx="1554480" cy="1554479"/>
           </a:xfrm>
           <a:prstGeom prst="rect">
@@ -5718,7 +6427,7 @@
               </a:spcAft>
             </a:pPr>
             <a:r>
-              <a:rPr sz="1100" b="0">
+              <a:rPr sz="1100" b="0" dirty="0" err="1">
                 <a:solidFill>
                   <a:srgbClr val="1C2428"/>
                 </a:solidFill>
@@ -5727,6 +6436,13 @@
               </a:rPr>
               <a:t>唯一功能：rag_retrieve</a:t>
             </a:r>
+            <a:endParaRPr sz="1100" b="0" dirty="0">
+              <a:solidFill>
+                <a:srgbClr val="1C2428"/>
+              </a:solidFill>
+              <a:latin typeface="Microsoft JhengHei"/>
+              <a:ea typeface="Microsoft JhengHei"/>
+            </a:endParaRPr>
           </a:p>
         </p:txBody>
       </p:sp>
@@ -5785,11 +6501,11 @@
             <a:avLst/>
           </a:prstGeom>
           <a:solidFill>
-            <a:srgbClr val="FFFFFF"/>
+            <a:srgbClr val="E6F4F2"/>
           </a:solidFill>
           <a:ln w="12700">
             <a:solidFill>
-              <a:srgbClr val="D4D8D6"/>
+              <a:srgbClr val="1F8A80"/>
             </a:solidFill>
           </a:ln>
         </p:spPr>
@@ -5812,6 +6528,7 @@
           <a:lstStyle/>
           <a:p>
             <a:pPr algn="ctr"/>
+            <a:endParaRPr/>
           </a:p>
         </p:txBody>
       </p:sp>
@@ -5863,7 +6580,7 @@
         </p:nvSpPr>
         <p:spPr>
           <a:xfrm>
-            <a:off x="9875519" y="2514600"/>
+            <a:off x="9826905" y="2933489"/>
             <a:ext cx="1554480" cy="1554479"/>
           </a:xfrm>
           <a:prstGeom prst="rect">
@@ -5883,15 +6600,52 @@
               </a:spcAft>
             </a:pPr>
             <a:r>
-              <a:rPr sz="1100" b="0">
+              <a:rPr sz="1100" b="0" dirty="0">
                 <a:solidFill>
                   <a:srgbClr val="1C2428"/>
                 </a:solidFill>
                 <a:latin typeface="Microsoft JhengHei"/>
                 <a:ea typeface="Microsoft JhengHei"/>
               </a:rPr>
-              <a:t>SQL 校務表 ＋ campus-docs.json</a:t>
-            </a:r>
+              <a:t>SQL </a:t>
+            </a:r>
+            <a:r>
+              <a:rPr sz="1100" b="0" dirty="0" err="1">
+                <a:solidFill>
+                  <a:srgbClr val="1C2428"/>
+                </a:solidFill>
+                <a:latin typeface="Microsoft JhengHei"/>
+                <a:ea typeface="Microsoft JhengHei"/>
+              </a:rPr>
+              <a:t>校務表</a:t>
+            </a:r>
+            <a:r>
+              <a:rPr sz="1100" b="0" dirty="0">
+                <a:solidFill>
+                  <a:srgbClr val="1C2428"/>
+                </a:solidFill>
+                <a:latin typeface="Microsoft JhengHei"/>
+                <a:ea typeface="Microsoft JhengHei"/>
+              </a:rPr>
+              <a:t> ＋ campus-</a:t>
+            </a:r>
+            <a:r>
+              <a:rPr sz="1100" b="0" dirty="0" err="1">
+                <a:solidFill>
+                  <a:srgbClr val="1C2428"/>
+                </a:solidFill>
+                <a:latin typeface="Microsoft JhengHei"/>
+                <a:ea typeface="Microsoft JhengHei"/>
+              </a:rPr>
+              <a:t>docs.json</a:t>
+            </a:r>
+            <a:endParaRPr sz="1100" b="0" dirty="0">
+              <a:solidFill>
+                <a:srgbClr val="1C2428"/>
+              </a:solidFill>
+              <a:latin typeface="Microsoft JhengHei"/>
+              <a:ea typeface="Microsoft JhengHei"/>
+            </a:endParaRPr>
           </a:p>
         </p:txBody>
       </p:sp>
@@ -5977,6 +6731,7 @@
           <a:lstStyle/>
           <a:p>
             <a:pPr algn="ctr"/>
+            <a:endParaRPr/>
           </a:p>
         </p:txBody>
       </p:sp>
@@ -6086,7 +6841,7 @@
 </file>
 
 <file path=ppt/slides/slide4.xml><?xml version="1.0" encoding="utf-8"?>
-<p:sld xmlns:a="http://schemas.openxmlformats.org/drawingml/2006/main" xmlns:p="http://schemas.openxmlformats.org/presentationml/2006/main" xmlns:r="http://schemas.openxmlformats.org/officeDocument/2006/relationships">
+<p:sld xmlns:a="http://schemas.openxmlformats.org/drawingml/2006/main" xmlns:r="http://schemas.openxmlformats.org/officeDocument/2006/relationships" xmlns:p="http://schemas.openxmlformats.org/presentationml/2006/main">
   <p:cSld>
     <p:spTree>
       <p:nvGrpSpPr>
@@ -6094,7 +6849,14 @@
         <p:cNvGrpSpPr/>
         <p:nvPr/>
       </p:nvGrpSpPr>
-      <p:grpSpPr/>
+      <p:grpSpPr>
+        <a:xfrm>
+          <a:off x="0" y="0"/>
+          <a:ext cx="0" cy="0"/>
+          <a:chOff x="0" y="0"/>
+          <a:chExt cx="0" cy="0"/>
+        </a:xfrm>
+      </p:grpSpPr>
       <p:pic>
         <p:nvPicPr>
           <p:cNvPr id="2" name="Picture 1" descr="slide-bg-campus-plain.png"/>
@@ -6119,46 +6881,6 @@
           </a:prstGeom>
         </p:spPr>
       </p:pic>
-      <p:sp>
-        <p:nvSpPr>
-          <p:cNvPr id="3" name="TextBox 2"/>
-          <p:cNvSpPr txBox="1"/>
-          <p:nvPr/>
-        </p:nvSpPr>
-        <p:spPr>
-          <a:xfrm>
-            <a:off x="640080" y="320040"/>
-            <a:ext cx="9144000" cy="256032"/>
-          </a:xfrm>
-          <a:prstGeom prst="rect">
-            <a:avLst/>
-          </a:prstGeom>
-          <a:noFill/>
-        </p:spPr>
-        <p:txBody>
-          <a:bodyPr wrap="square">
-            <a:spAutoFit/>
-          </a:bodyPr>
-          <a:lstStyle/>
-          <a:p>
-            <a:pPr algn="l">
-              <a:spcAft>
-                <a:spcPts val="600"/>
-              </a:spcAft>
-            </a:pPr>
-            <a:r>
-              <a:rPr sz="1200" b="1">
-                <a:solidFill>
-                  <a:srgbClr val="1F8A80"/>
-                </a:solidFill>
-                <a:latin typeface="Microsoft JhengHei"/>
-                <a:ea typeface="Microsoft JhengHei"/>
-              </a:rPr>
-              <a:t>Campus AI</a:t>
-            </a:r>
-          </a:p>
-        </p:txBody>
-      </p:sp>
       <p:sp>
         <p:nvSpPr>
           <p:cNvPr id="4" name="TextBox 3"/>
@@ -6321,6 +7043,7 @@
           <a:lstStyle/>
           <a:p>
             <a:pPr algn="ctr"/>
+            <a:endParaRPr/>
           </a:p>
         </p:txBody>
       </p:sp>
@@ -6446,6 +7169,7 @@
           <a:lstStyle/>
           <a:p>
             <a:pPr algn="ctr"/>
+            <a:endParaRPr/>
           </a:p>
         </p:txBody>
       </p:sp>
@@ -6571,6 +7295,7 @@
           <a:lstStyle/>
           <a:p>
             <a:pPr algn="ctr"/>
+            <a:endParaRPr/>
           </a:p>
         </p:txBody>
       </p:sp>
@@ -6696,6 +7421,7 @@
           <a:lstStyle/>
           <a:p>
             <a:pPr algn="ctr"/>
+            <a:endParaRPr/>
           </a:p>
         </p:txBody>
       </p:sp>
@@ -6788,7 +7514,7 @@
 </file>
 
 <file path=ppt/slides/slide5.xml><?xml version="1.0" encoding="utf-8"?>
-<p:sld xmlns:a="http://schemas.openxmlformats.org/drawingml/2006/main" xmlns:p="http://schemas.openxmlformats.org/presentationml/2006/main" xmlns:r="http://schemas.openxmlformats.org/officeDocument/2006/relationships">
+<p:sld xmlns:a="http://schemas.openxmlformats.org/drawingml/2006/main" xmlns:r="http://schemas.openxmlformats.org/officeDocument/2006/relationships" xmlns:p="http://schemas.openxmlformats.org/presentationml/2006/main">
   <p:cSld>
     <p:spTree>
       <p:nvGrpSpPr>
@@ -6796,7 +7522,14 @@
         <p:cNvGrpSpPr/>
         <p:nvPr/>
       </p:nvGrpSpPr>
-      <p:grpSpPr/>
+      <p:grpSpPr>
+        <a:xfrm>
+          <a:off x="0" y="0"/>
+          <a:ext cx="0" cy="0"/>
+          <a:chOff x="0" y="0"/>
+          <a:chExt cx="0" cy="0"/>
+        </a:xfrm>
+      </p:grpSpPr>
       <p:pic>
         <p:nvPicPr>
           <p:cNvPr id="2" name="Picture 1" descr="slide-bg-campus-plain.png"/>
@@ -6806,7 +7539,7 @@
           <p:nvPr/>
         </p:nvPicPr>
         <p:blipFill>
-          <a:blip r:embed="rId2"/>
+          <a:blip r:embed="rId3"/>
           <a:stretch>
             <a:fillRect/>
           </a:stretch>
@@ -6821,46 +7554,6 @@
           </a:prstGeom>
         </p:spPr>
       </p:pic>
-      <p:sp>
-        <p:nvSpPr>
-          <p:cNvPr id="3" name="TextBox 2"/>
-          <p:cNvSpPr txBox="1"/>
-          <p:nvPr/>
-        </p:nvSpPr>
-        <p:spPr>
-          <a:xfrm>
-            <a:off x="640080" y="320040"/>
-            <a:ext cx="9144000" cy="256032"/>
-          </a:xfrm>
-          <a:prstGeom prst="rect">
-            <a:avLst/>
-          </a:prstGeom>
-          <a:noFill/>
-        </p:spPr>
-        <p:txBody>
-          <a:bodyPr wrap="square">
-            <a:spAutoFit/>
-          </a:bodyPr>
-          <a:lstStyle/>
-          <a:p>
-            <a:pPr algn="l">
-              <a:spcAft>
-                <a:spcPts val="600"/>
-              </a:spcAft>
-            </a:pPr>
-            <a:r>
-              <a:rPr sz="1200" b="1">
-                <a:solidFill>
-                  <a:srgbClr val="1F8A80"/>
-                </a:solidFill>
-                <a:latin typeface="Microsoft JhengHei"/>
-                <a:ea typeface="Microsoft JhengHei"/>
-              </a:rPr>
-              <a:t>Campus AI</a:t>
-            </a:r>
-          </a:p>
-        </p:txBody>
-      </p:sp>
       <p:sp>
         <p:nvSpPr>
           <p:cNvPr id="4" name="TextBox 3"/>
@@ -7023,6 +7716,7 @@
           <a:lstStyle/>
           <a:p>
             <a:pPr algn="ctr"/>
+            <a:endParaRPr/>
           </a:p>
         </p:txBody>
       </p:sp>
@@ -7035,34 +7729,51 @@
         <p:spPr>
           <a:xfrm>
             <a:off x="868680" y="1554480"/>
-            <a:ext cx="4754880" cy="320040"/>
-          </a:xfrm>
-          <a:prstGeom prst="rect">
-            <a:avLst/>
-          </a:prstGeom>
-          <a:noFill/>
-        </p:spPr>
-        <p:txBody>
-          <a:bodyPr wrap="square">
-            <a:spAutoFit/>
-          </a:bodyPr>
-          <a:lstStyle/>
-          <a:p>
-            <a:pPr algn="l">
+            <a:ext cx="4754880" cy="338554"/>
+          </a:xfrm>
+          <a:prstGeom prst="rect">
+            <a:avLst/>
+          </a:prstGeom>
+          <a:noFill/>
+        </p:spPr>
+        <p:txBody>
+          <a:bodyPr wrap="square">
+            <a:spAutoFit/>
+          </a:bodyPr>
+          <a:lstStyle/>
+          <a:p>
+            <a:pPr>
               <a:spcAft>
                 <a:spcPts val="600"/>
               </a:spcAft>
             </a:pPr>
             <a:r>
-              <a:rPr sz="1600" b="1">
+              <a:rPr lang="en-US" altLang="zh-TW" sz="1600" b="1" dirty="0" err="1">
                 <a:solidFill>
                   <a:srgbClr val="1F8A80"/>
                 </a:solidFill>
                 <a:latin typeface="Microsoft JhengHei"/>
                 <a:ea typeface="Microsoft JhengHei"/>
               </a:rPr>
+              <a:t>Server</a:t>
+            </a:r>
+            <a:r>
+              <a:rPr sz="1600" b="1" dirty="0" err="1">
+                <a:solidFill>
+                  <a:srgbClr val="1F8A80"/>
+                </a:solidFill>
+                <a:latin typeface="Microsoft JhengHei"/>
+                <a:ea typeface="Microsoft JhengHei"/>
+              </a:rPr>
               <a:t>服務基本配置</a:t>
             </a:r>
+            <a:endParaRPr sz="1600" b="1" dirty="0">
+              <a:solidFill>
+                <a:srgbClr val="1F8A80"/>
+              </a:solidFill>
+              <a:latin typeface="Microsoft JhengHei"/>
+              <a:ea typeface="Microsoft JhengHei"/>
+            </a:endParaRPr>
           </a:p>
         </p:txBody>
       </p:sp>
@@ -7094,15 +7805,22 @@
               </a:spcAft>
             </a:pPr>
             <a:r>
-              <a:rPr sz="1200" b="0">
+              <a:rPr sz="1200" b="0" dirty="0" err="1">
                 <a:solidFill>
                   <a:srgbClr val="5A656B"/>
                 </a:solidFill>
                 <a:latin typeface="Microsoft JhengHei"/>
                 <a:ea typeface="Microsoft JhengHei"/>
               </a:rPr>
-              <a:t>專案名稱</a:t>
-            </a:r>
+              <a:t>名稱</a:t>
+            </a:r>
+            <a:endParaRPr sz="1200" b="0" dirty="0">
+              <a:solidFill>
+                <a:srgbClr val="5A656B"/>
+              </a:solidFill>
+              <a:latin typeface="Microsoft JhengHei"/>
+              <a:ea typeface="Microsoft JhengHei"/>
+            </a:endParaRPr>
           </a:p>
         </p:txBody>
       </p:sp>
@@ -7174,15 +7892,22 @@
               </a:spcAft>
             </a:pPr>
             <a:r>
-              <a:rPr sz="1200" b="0">
+              <a:rPr sz="1200" b="0" dirty="0" err="1">
                 <a:solidFill>
                   <a:srgbClr val="5A656B"/>
                 </a:solidFill>
                 <a:latin typeface="Microsoft JhengHei"/>
                 <a:ea typeface="Microsoft JhengHei"/>
               </a:rPr>
-              <a:t>通訊協定</a:t>
-            </a:r>
+              <a:t>協定</a:t>
+            </a:r>
+            <a:endParaRPr sz="1200" b="0" dirty="0">
+              <a:solidFill>
+                <a:srgbClr val="5A656B"/>
+              </a:solidFill>
+              <a:latin typeface="Microsoft JhengHei"/>
+              <a:ea typeface="Microsoft JhengHei"/>
+            </a:endParaRPr>
           </a:p>
         </p:txBody>
       </p:sp>
@@ -7254,14 +7979,24 @@
               </a:spcAft>
             </a:pPr>
             <a:r>
-              <a:rPr sz="1200" b="0">
+              <a:rPr sz="1200" b="0" dirty="0" err="1">
                 <a:solidFill>
                   <a:srgbClr val="5A656B"/>
                 </a:solidFill>
                 <a:latin typeface="Microsoft JhengHei"/>
                 <a:ea typeface="Microsoft JhengHei"/>
               </a:rPr>
-              <a:t>單一開放 Tool</a:t>
+              <a:t>單一開放</a:t>
+            </a:r>
+            <a:r>
+              <a:rPr sz="1200" b="0" dirty="0">
+                <a:solidFill>
+                  <a:srgbClr val="5A656B"/>
+                </a:solidFill>
+                <a:latin typeface="Microsoft JhengHei"/>
+                <a:ea typeface="Microsoft JhengHei"/>
+              </a:rPr>
+              <a:t> Tool</a:t>
             </a:r>
           </a:p>
         </p:txBody>
@@ -7406,23 +8141,33 @@
           <a:bodyPr wrap="square">
             <a:spAutoFit/>
           </a:bodyPr>
-          <a:lstStyle/>
-          <a:p>
-            <a:pPr algn="l">
+          <a:lstStyle>
+            <a:defPPr>
+              <a:defRPr lang="en-US"/>
+            </a:defPPr>
+            <a:lvl1pPr>
               <a:spcAft>
                 <a:spcPts val="600"/>
               </a:spcAft>
-            </a:pPr>
-            <a:r>
-              <a:rPr sz="1500" b="1">
-                <a:solidFill>
-                  <a:srgbClr val="1C2428"/>
-                </a:solidFill>
-                <a:latin typeface="Microsoft JhengHei"/>
-                <a:ea typeface="Microsoft JhengHei"/>
-              </a:rPr>
-              <a:t>Server 絕對不做的事</a:t>
-            </a:r>
+              <a:defRPr sz="1600" b="1">
+                <a:solidFill>
+                  <a:srgbClr val="1F8A80"/>
+                </a:solidFill>
+                <a:latin typeface="Microsoft JhengHei"/>
+                <a:ea typeface="Microsoft JhengHei"/>
+              </a:defRPr>
+            </a:lvl1pPr>
+          </a:lstStyle>
+          <a:p>
+            <a:r>
+              <a:rPr dirty="0"/>
+              <a:t>Server </a:t>
+            </a:r>
+            <a:r>
+              <a:rPr lang="zh-TW" altLang="en-US" dirty="0"/>
+              <a:t>未處理</a:t>
+            </a:r>
+            <a:endParaRPr dirty="0"/>
           </a:p>
         </p:txBody>
       </p:sp>
@@ -7588,6 +8333,7 @@
           <a:lstStyle/>
           <a:p>
             <a:pPr algn="ctr"/>
+            <a:endParaRPr/>
           </a:p>
         </p:txBody>
       </p:sp>
@@ -7867,6 +8613,7 @@
           <a:lstStyle/>
           <a:p>
             <a:pPr algn="ctr"/>
+            <a:endParaRPr/>
           </a:p>
         </p:txBody>
       </p:sp>
@@ -7879,7 +8626,7 @@
         <p:spPr>
           <a:xfrm>
             <a:off x="6583680" y="5257800"/>
-            <a:ext cx="4389120" cy="457200"/>
+            <a:ext cx="4389120" cy="307777"/>
           </a:xfrm>
           <a:prstGeom prst="rect">
             <a:avLst/>
@@ -7898,14 +8645,34 @@
               </a:spcAft>
             </a:pPr>
             <a:r>
-              <a:rPr sz="1400" b="1">
+              <a:rPr sz="1400" b="1" dirty="0">
                 <a:solidFill>
                   <a:srgbClr val="1F8A80"/>
                 </a:solidFill>
                 <a:latin typeface="Microsoft JhengHei"/>
                 <a:ea typeface="Microsoft JhengHei"/>
               </a:rPr>
-              <a:t>一句話：Server 只檢索，不聊天。</a:t>
+              <a:t>Server </a:t>
+            </a:r>
+            <a:r>
+              <a:rPr sz="1400" b="1" dirty="0" err="1">
+                <a:solidFill>
+                  <a:srgbClr val="1F8A80"/>
+                </a:solidFill>
+                <a:latin typeface="Microsoft JhengHei"/>
+                <a:ea typeface="Microsoft JhengHei"/>
+              </a:rPr>
+              <a:t>只檢索，不聊天</a:t>
+            </a:r>
+            <a:r>
+              <a:rPr sz="1400" b="1" dirty="0">
+                <a:solidFill>
+                  <a:srgbClr val="1F8A80"/>
+                </a:solidFill>
+                <a:latin typeface="Microsoft JhengHei"/>
+                <a:ea typeface="Microsoft JhengHei"/>
+              </a:rPr>
+              <a:t>。</a:t>
             </a:r>
           </a:p>
         </p:txBody>
@@ -7919,7 +8686,7 @@
 </file>
 
 <file path=ppt/slides/slide6.xml><?xml version="1.0" encoding="utf-8"?>
-<p:sld xmlns:a="http://schemas.openxmlformats.org/drawingml/2006/main" xmlns:p="http://schemas.openxmlformats.org/presentationml/2006/main" xmlns:r="http://schemas.openxmlformats.org/officeDocument/2006/relationships">
+<p:sld xmlns:a="http://schemas.openxmlformats.org/drawingml/2006/main" xmlns:r="http://schemas.openxmlformats.org/officeDocument/2006/relationships" xmlns:p="http://schemas.openxmlformats.org/presentationml/2006/main">
   <p:cSld>
     <p:spTree>
       <p:nvGrpSpPr>
@@ -7927,7 +8694,14 @@
         <p:cNvGrpSpPr/>
         <p:nvPr/>
       </p:nvGrpSpPr>
-      <p:grpSpPr/>
+      <p:grpSpPr>
+        <a:xfrm>
+          <a:off x="0" y="0"/>
+          <a:ext cx="0" cy="0"/>
+          <a:chOff x="0" y="0"/>
+          <a:chExt cx="0" cy="0"/>
+        </a:xfrm>
+      </p:grpSpPr>
       <p:pic>
         <p:nvPicPr>
           <p:cNvPr id="2" name="Picture 1" descr="slide-bg-campus-plain.png"/>
@@ -7952,46 +8726,6 @@
           </a:prstGeom>
         </p:spPr>
       </p:pic>
-      <p:sp>
-        <p:nvSpPr>
-          <p:cNvPr id="3" name="TextBox 2"/>
-          <p:cNvSpPr txBox="1"/>
-          <p:nvPr/>
-        </p:nvSpPr>
-        <p:spPr>
-          <a:xfrm>
-            <a:off x="640080" y="320040"/>
-            <a:ext cx="9144000" cy="256032"/>
-          </a:xfrm>
-          <a:prstGeom prst="rect">
-            <a:avLst/>
-          </a:prstGeom>
-          <a:noFill/>
-        </p:spPr>
-        <p:txBody>
-          <a:bodyPr wrap="square">
-            <a:spAutoFit/>
-          </a:bodyPr>
-          <a:lstStyle/>
-          <a:p>
-            <a:pPr algn="l">
-              <a:spcAft>
-                <a:spcPts val="600"/>
-              </a:spcAft>
-            </a:pPr>
-            <a:r>
-              <a:rPr sz="1200" b="1">
-                <a:solidFill>
-                  <a:srgbClr val="1F8A80"/>
-                </a:solidFill>
-                <a:latin typeface="Microsoft JhengHei"/>
-                <a:ea typeface="Microsoft JhengHei"/>
-              </a:rPr>
-              <a:t>Campus AI</a:t>
-            </a:r>
-          </a:p>
-        </p:txBody>
-      </p:sp>
       <p:sp>
         <p:nvSpPr>
           <p:cNvPr id="4" name="TextBox 3"/>
@@ -8154,6 +8888,7 @@
           <a:lstStyle/>
           <a:p>
             <a:pPr algn="ctr"/>
+            <a:endParaRPr/>
           </a:p>
         </p:txBody>
       </p:sp>
@@ -8433,6 +9168,7 @@
           <a:lstStyle/>
           <a:p>
             <a:pPr algn="ctr"/>
+            <a:endParaRPr/>
           </a:p>
         </p:txBody>
       </p:sp>
@@ -8758,6 +9494,7 @@
           <a:lstStyle/>
           <a:p>
             <a:pPr algn="ctr"/>
+            <a:endParaRPr/>
           </a:p>
         </p:txBody>
       </p:sp>
@@ -8810,7 +9547,7 @@
 </file>
 
 <file path=ppt/slides/slide7.xml><?xml version="1.0" encoding="utf-8"?>
-<p:sld xmlns:a="http://schemas.openxmlformats.org/drawingml/2006/main" xmlns:p="http://schemas.openxmlformats.org/presentationml/2006/main" xmlns:r="http://schemas.openxmlformats.org/officeDocument/2006/relationships">
+<p:sld xmlns:a="http://schemas.openxmlformats.org/drawingml/2006/main" xmlns:r="http://schemas.openxmlformats.org/officeDocument/2006/relationships" xmlns:p="http://schemas.openxmlformats.org/presentationml/2006/main">
   <p:cSld>
     <p:spTree>
       <p:nvGrpSpPr>
@@ -8818,7 +9555,14 @@
         <p:cNvGrpSpPr/>
         <p:nvPr/>
       </p:nvGrpSpPr>
-      <p:grpSpPr/>
+      <p:grpSpPr>
+        <a:xfrm>
+          <a:off x="0" y="0"/>
+          <a:ext cx="0" cy="0"/>
+          <a:chOff x="0" y="0"/>
+          <a:chExt cx="0" cy="0"/>
+        </a:xfrm>
+      </p:grpSpPr>
       <p:pic>
         <p:nvPicPr>
           <p:cNvPr id="2" name="Picture 1" descr="slide-bg-campus-plain.png"/>
@@ -8845,14 +9589,14 @@
       </p:pic>
       <p:sp>
         <p:nvSpPr>
-          <p:cNvPr id="3" name="TextBox 2"/>
-          <p:cNvSpPr txBox="1"/>
-          <p:nvPr/>
-        </p:nvSpPr>
-        <p:spPr>
-          <a:xfrm>
-            <a:off x="640080" y="320040"/>
-            <a:ext cx="9144000" cy="256032"/>
+          <p:cNvPr id="4" name="TextBox 3"/>
+          <p:cNvSpPr txBox="1"/>
+          <p:nvPr/>
+        </p:nvSpPr>
+        <p:spPr>
+          <a:xfrm>
+            <a:off x="640080" y="576072"/>
+            <a:ext cx="9601200" cy="492443"/>
           </a:xfrm>
           <a:prstGeom prst="rect">
             <a:avLst/>
@@ -8871,55 +9615,32 @@
               </a:spcAft>
             </a:pPr>
             <a:r>
-              <a:rPr sz="1200" b="1">
-                <a:solidFill>
-                  <a:srgbClr val="1F8A80"/>
-                </a:solidFill>
-                <a:latin typeface="Microsoft JhengHei"/>
-                <a:ea typeface="Microsoft JhengHei"/>
-              </a:rPr>
-              <a:t>Campus AI</a:t>
-            </a:r>
-          </a:p>
-        </p:txBody>
-      </p:sp>
-      <p:sp>
-        <p:nvSpPr>
-          <p:cNvPr id="4" name="TextBox 3"/>
-          <p:cNvSpPr txBox="1"/>
-          <p:nvPr/>
-        </p:nvSpPr>
-        <p:spPr>
-          <a:xfrm>
-            <a:off x="640080" y="576072"/>
-            <a:ext cx="9601200" cy="411480"/>
-          </a:xfrm>
-          <a:prstGeom prst="rect">
-            <a:avLst/>
-          </a:prstGeom>
-          <a:noFill/>
-        </p:spPr>
-        <p:txBody>
-          <a:bodyPr wrap="square">
-            <a:spAutoFit/>
-          </a:bodyPr>
-          <a:lstStyle/>
-          <a:p>
-            <a:pPr algn="l">
-              <a:spcAft>
-                <a:spcPts val="600"/>
-              </a:spcAft>
-            </a:pPr>
-            <a:r>
-              <a:rPr sz="2600" b="1">
+              <a:rPr sz="2600" b="1" dirty="0">
                 <a:solidFill>
                   <a:srgbClr val="1C2428"/>
                 </a:solidFill>
                 <a:latin typeface="Microsoft JhengHei"/>
                 <a:ea typeface="Microsoft JhengHei"/>
               </a:rPr>
-              <a:t>一輪請求怎麼走</a:t>
-            </a:r>
+              <a:t>請</a:t>
+            </a:r>
+            <a:r>
+              <a:rPr lang="zh-TW" altLang="en-US" sz="2600" b="1" dirty="0">
+                <a:solidFill>
+                  <a:srgbClr val="1C2428"/>
+                </a:solidFill>
+                <a:latin typeface="Microsoft JhengHei"/>
+                <a:ea typeface="Microsoft JhengHei"/>
+              </a:rPr>
+              <a:t>求路徑</a:t>
+            </a:r>
+            <a:endParaRPr sz="2600" b="1" dirty="0">
+              <a:solidFill>
+                <a:srgbClr val="1C2428"/>
+              </a:solidFill>
+              <a:latin typeface="Microsoft JhengHei"/>
+              <a:ea typeface="Microsoft JhengHei"/>
+            </a:endParaRPr>
           </a:p>
         </p:txBody>
       </p:sp>
@@ -9045,6 +9766,7 @@
           <a:lstStyle/>
           <a:p>
             <a:pPr algn="ctr"/>
+            <a:endParaRPr/>
           </a:p>
         </p:txBody>
       </p:sp>
@@ -9170,6 +9892,7 @@
           <a:lstStyle/>
           <a:p>
             <a:pPr algn="ctr"/>
+            <a:endParaRPr/>
           </a:p>
         </p:txBody>
       </p:sp>
@@ -9295,6 +10018,7 @@
           <a:lstStyle/>
           <a:p>
             <a:pPr algn="ctr"/>
+            <a:endParaRPr/>
           </a:p>
         </p:txBody>
       </p:sp>
@@ -9420,6 +10144,7 @@
           <a:lstStyle/>
           <a:p>
             <a:pPr algn="ctr"/>
+            <a:endParaRPr/>
           </a:p>
         </p:txBody>
       </p:sp>
@@ -9545,6 +10270,7 @@
           <a:lstStyle/>
           <a:p>
             <a:pPr algn="ctr"/>
+            <a:endParaRPr/>
           </a:p>
         </p:txBody>
       </p:sp>
@@ -9670,6 +10396,7 @@
           <a:lstStyle/>
           <a:p>
             <a:pPr algn="ctr"/>
+            <a:endParaRPr/>
           </a:p>
         </p:txBody>
       </p:sp>
@@ -9795,6 +10522,7 @@
           <a:lstStyle/>
           <a:p>
             <a:pPr algn="ctr"/>
+            <a:endParaRPr/>
           </a:p>
         </p:txBody>
       </p:sp>
@@ -9920,6 +10648,7 @@
           <a:lstStyle/>
           <a:p>
             <a:pPr algn="ctr"/>
+            <a:endParaRPr/>
           </a:p>
         </p:txBody>
       </p:sp>
@@ -10046,7 +10775,7 @@
 </file>
 
 <file path=ppt/slides/slide8.xml><?xml version="1.0" encoding="utf-8"?>
-<p:sld xmlns:a="http://schemas.openxmlformats.org/drawingml/2006/main" xmlns:p="http://schemas.openxmlformats.org/presentationml/2006/main" xmlns:r="http://schemas.openxmlformats.org/officeDocument/2006/relationships">
+<p:sld xmlns:a="http://schemas.openxmlformats.org/drawingml/2006/main" xmlns:r="http://schemas.openxmlformats.org/officeDocument/2006/relationships" xmlns:p="http://schemas.openxmlformats.org/presentationml/2006/main">
   <p:cSld>
     <p:spTree>
       <p:nvGrpSpPr>
@@ -10054,7 +10783,14 @@
         <p:cNvGrpSpPr/>
         <p:nvPr/>
       </p:nvGrpSpPr>
-      <p:grpSpPr/>
+      <p:grpSpPr>
+        <a:xfrm>
+          <a:off x="0" y="0"/>
+          <a:ext cx="0" cy="0"/>
+          <a:chOff x="0" y="0"/>
+          <a:chExt cx="0" cy="0"/>
+        </a:xfrm>
+      </p:grpSpPr>
       <p:pic>
         <p:nvPicPr>
           <p:cNvPr id="2" name="Picture 1" descr="slide-bg-campus-plain.png"/>
@@ -10081,14 +10817,14 @@
       </p:pic>
       <p:sp>
         <p:nvSpPr>
-          <p:cNvPr id="3" name="TextBox 2"/>
-          <p:cNvSpPr txBox="1"/>
-          <p:nvPr/>
-        </p:nvSpPr>
-        <p:spPr>
-          <a:xfrm>
-            <a:off x="640080" y="320040"/>
-            <a:ext cx="9144000" cy="256032"/>
+          <p:cNvPr id="4" name="TextBox 3"/>
+          <p:cNvSpPr txBox="1"/>
+          <p:nvPr/>
+        </p:nvSpPr>
+        <p:spPr>
+          <a:xfrm>
+            <a:off x="640080" y="576072"/>
+            <a:ext cx="9601200" cy="492443"/>
           </a:xfrm>
           <a:prstGeom prst="rect">
             <a:avLst/>
@@ -10107,55 +10843,22 @@
               </a:spcAft>
             </a:pPr>
             <a:r>
-              <a:rPr sz="1200" b="1">
-                <a:solidFill>
-                  <a:srgbClr val="1F8A80"/>
-                </a:solidFill>
-                <a:latin typeface="Microsoft JhengHei"/>
-                <a:ea typeface="Microsoft JhengHei"/>
-              </a:rPr>
-              <a:t>Campus AI</a:t>
-            </a:r>
-          </a:p>
-        </p:txBody>
-      </p:sp>
-      <p:sp>
-        <p:nvSpPr>
-          <p:cNvPr id="4" name="TextBox 3"/>
-          <p:cNvSpPr txBox="1"/>
-          <p:nvPr/>
-        </p:nvSpPr>
-        <p:spPr>
-          <a:xfrm>
-            <a:off x="640080" y="576072"/>
-            <a:ext cx="9601200" cy="411480"/>
-          </a:xfrm>
-          <a:prstGeom prst="rect">
-            <a:avLst/>
-          </a:prstGeom>
-          <a:noFill/>
-        </p:spPr>
-        <p:txBody>
-          <a:bodyPr wrap="square">
-            <a:spAutoFit/>
-          </a:bodyPr>
-          <a:lstStyle/>
-          <a:p>
-            <a:pPr algn="l">
-              <a:spcAft>
-                <a:spcPts val="600"/>
-              </a:spcAft>
-            </a:pPr>
-            <a:r>
-              <a:rPr sz="2600" b="1">
+              <a:rPr lang="zh-TW" altLang="en-US" sz="2600" b="1" dirty="0">
                 <a:solidFill>
                   <a:srgbClr val="1C2428"/>
                 </a:solidFill>
                 <a:latin typeface="Microsoft JhengHei"/>
                 <a:ea typeface="Microsoft JhengHei"/>
               </a:rPr>
-              <a:t>現場示範</a:t>
-            </a:r>
+              <a:t>簡易測試</a:t>
+            </a:r>
+            <a:endParaRPr sz="2600" b="1" dirty="0">
+              <a:solidFill>
+                <a:srgbClr val="1C2428"/>
+              </a:solidFill>
+              <a:latin typeface="Microsoft JhengHei"/>
+              <a:ea typeface="Microsoft JhengHei"/>
+            </a:endParaRPr>
           </a:p>
         </p:txBody>
       </p:sp>
@@ -10281,6 +10984,7 @@
           <a:lstStyle/>
           <a:p>
             <a:pPr algn="ctr"/>
+            <a:endParaRPr/>
           </a:p>
         </p:txBody>
       </p:sp>
@@ -10406,6 +11110,7 @@
           <a:lstStyle/>
           <a:p>
             <a:pPr algn="ctr"/>
+            <a:endParaRPr/>
           </a:p>
         </p:txBody>
       </p:sp>
@@ -10491,6 +11196,7 @@
           <a:lstStyle/>
           <a:p>
             <a:pPr algn="ctr"/>
+            <a:endParaRPr/>
           </a:p>
         </p:txBody>
       </p:sp>
@@ -10616,6 +11322,7 @@
           <a:lstStyle/>
           <a:p>
             <a:pPr algn="ctr"/>
+            <a:endParaRPr/>
           </a:p>
         </p:txBody>
       </p:sp>
@@ -10701,6 +11408,7 @@
           <a:lstStyle/>
           <a:p>
             <a:pPr algn="ctr"/>
+            <a:endParaRPr/>
           </a:p>
         </p:txBody>
       </p:sp>
@@ -10826,6 +11534,7 @@
           <a:lstStyle/>
           <a:p>
             <a:pPr algn="ctr"/>
+            <a:endParaRPr/>
           </a:p>
         </p:txBody>
       </p:sp>
@@ -10911,6 +11620,7 @@
           <a:lstStyle/>
           <a:p>
             <a:pPr algn="ctr"/>
+            <a:endParaRPr/>
           </a:p>
         </p:txBody>
       </p:sp>
@@ -10963,7 +11673,7 @@
         <p:spPr>
           <a:xfrm>
             <a:off x="868680" y="5623560"/>
-            <a:ext cx="10424160" cy="411480"/>
+            <a:ext cx="10424160" cy="323165"/>
           </a:xfrm>
           <a:prstGeom prst="rect">
             <a:avLst/>
@@ -10982,14 +11692,124 @@
               </a:spcAft>
             </a:pPr>
             <a:r>
-              <a:rPr sz="1500" b="1">
+              <a:rPr sz="1500" b="1" dirty="0" err="1">
                 <a:solidFill>
                   <a:srgbClr val="1C2428"/>
                 </a:solidFill>
                 <a:latin typeface="Microsoft JhengHei"/>
                 <a:ea typeface="Microsoft JhengHei"/>
               </a:rPr>
-              <a:t>入口依身分與功能分；校務資料在 SQL；問答找文件走 MCP；回覆由 Gemini 整理。</a:t>
+              <a:t>入口依身分與功能分</a:t>
+            </a:r>
+            <a:r>
+              <a:rPr lang="zh-TW" altLang="en-US" sz="1500" b="1" dirty="0">
+                <a:solidFill>
+                  <a:srgbClr val="1C2428"/>
+                </a:solidFill>
+                <a:latin typeface="Microsoft JhengHei"/>
+                <a:ea typeface="Microsoft JhengHei"/>
+              </a:rPr>
+              <a:t>，</a:t>
+            </a:r>
+            <a:r>
+              <a:rPr sz="1500" b="1" dirty="0" err="1">
+                <a:solidFill>
+                  <a:srgbClr val="1C2428"/>
+                </a:solidFill>
+                <a:latin typeface="Microsoft JhengHei"/>
+                <a:ea typeface="Microsoft JhengHei"/>
+              </a:rPr>
+              <a:t>校務資料在</a:t>
+            </a:r>
+            <a:r>
+              <a:rPr sz="1500" b="1" dirty="0">
+                <a:solidFill>
+                  <a:srgbClr val="1C2428"/>
+                </a:solidFill>
+                <a:latin typeface="Microsoft JhengHei"/>
+                <a:ea typeface="Microsoft JhengHei"/>
+              </a:rPr>
+              <a:t> SQL</a:t>
+            </a:r>
+            <a:r>
+              <a:rPr lang="zh-TW" altLang="en-US" sz="1500" b="1" dirty="0">
+                <a:solidFill>
+                  <a:srgbClr val="1C2428"/>
+                </a:solidFill>
+                <a:latin typeface="Microsoft JhengHei"/>
+                <a:ea typeface="Microsoft JhengHei"/>
+              </a:rPr>
+              <a:t>，</a:t>
+            </a:r>
+            <a:r>
+              <a:rPr sz="1500" b="1" dirty="0" err="1">
+                <a:solidFill>
+                  <a:srgbClr val="1C2428"/>
+                </a:solidFill>
+                <a:latin typeface="Microsoft JhengHei"/>
+                <a:ea typeface="Microsoft JhengHei"/>
+              </a:rPr>
+              <a:t>問答找文件走</a:t>
+            </a:r>
+            <a:r>
+              <a:rPr sz="1500" b="1" dirty="0">
+                <a:solidFill>
+                  <a:srgbClr val="1C2428"/>
+                </a:solidFill>
+                <a:latin typeface="Microsoft JhengHei"/>
+                <a:ea typeface="Microsoft JhengHei"/>
+              </a:rPr>
+              <a:t> MCP</a:t>
+            </a:r>
+            <a:r>
+              <a:rPr lang="zh-TW" altLang="en-US" sz="1500" b="1" dirty="0">
+                <a:solidFill>
+                  <a:srgbClr val="1C2428"/>
+                </a:solidFill>
+                <a:latin typeface="Microsoft JhengHei"/>
+                <a:ea typeface="Microsoft JhengHei"/>
+              </a:rPr>
+              <a:t>，</a:t>
+            </a:r>
+            <a:r>
+              <a:rPr sz="1500" b="1" dirty="0" err="1">
+                <a:solidFill>
+                  <a:srgbClr val="1C2428"/>
+                </a:solidFill>
+                <a:latin typeface="Microsoft JhengHei"/>
+                <a:ea typeface="Microsoft JhengHei"/>
+              </a:rPr>
+              <a:t>回覆由</a:t>
+            </a:r>
+            <a:r>
+              <a:rPr sz="1500" b="1" dirty="0">
+                <a:solidFill>
+                  <a:srgbClr val="1C2428"/>
+                </a:solidFill>
+                <a:latin typeface="Microsoft JhengHei"/>
+                <a:ea typeface="Microsoft JhengHei"/>
+              </a:rPr>
+              <a:t> Gemini </a:t>
+            </a:r>
+            <a:r>
+              <a:rPr sz="1500" b="1" dirty="0" err="1">
+                <a:solidFill>
+                  <a:srgbClr val="1C2428"/>
+                </a:solidFill>
+                <a:latin typeface="Microsoft JhengHei"/>
+                <a:ea typeface="Microsoft JhengHei"/>
+              </a:rPr>
+              <a:t>整理</a:t>
+            </a:r>
+            <a:r>
+              <a:rPr sz="1500" b="1" dirty="0">
+                <a:solidFill>
+                  <a:srgbClr val="1C2428"/>
+                </a:solidFill>
+                <a:latin typeface="Microsoft JhengHei"/>
+                <a:ea typeface="Microsoft JhengHei"/>
+              </a:rPr>
+              <a:t>。</a:t>
             </a:r>
           </a:p>
         </p:txBody>
@@ -11003,7 +11823,7 @@
 </file>
 
 <file path=ppt/slides/slide9.xml><?xml version="1.0" encoding="utf-8"?>
-<p:sld xmlns:a="http://schemas.openxmlformats.org/drawingml/2006/main" xmlns:p="http://schemas.openxmlformats.org/presentationml/2006/main" xmlns:r="http://schemas.openxmlformats.org/officeDocument/2006/relationships">
+<p:sld xmlns:a="http://schemas.openxmlformats.org/drawingml/2006/main" xmlns:r="http://schemas.openxmlformats.org/officeDocument/2006/relationships" xmlns:p="http://schemas.openxmlformats.org/presentationml/2006/main">
   <p:cSld>
     <p:spTree>
       <p:nvGrpSpPr>
@@ -11011,7 +11831,14 @@
         <p:cNvGrpSpPr/>
         <p:nvPr/>
       </p:nvGrpSpPr>
-      <p:grpSpPr/>
+      <p:grpSpPr>
+        <a:xfrm>
+          <a:off x="0" y="0"/>
+          <a:ext cx="0" cy="0"/>
+          <a:chOff x="0" y="0"/>
+          <a:chExt cx="0" cy="0"/>
+        </a:xfrm>
+      </p:grpSpPr>
       <p:pic>
         <p:nvPicPr>
           <p:cNvPr id="2" name="Picture 1" descr="slide-bg-campus-plain.png"/>
@@ -11078,6 +11905,7 @@
           <a:lstStyle/>
           <a:p>
             <a:pPr algn="ctr"/>
+            <a:endParaRPr/>
           </a:p>
         </p:txBody>
       </p:sp>
@@ -11527,4 +12355,319 @@
   </a:objectDefaults>
   <a:extraClrSchemeLst/>
 </a:theme>
+</file>
+
+<file path=ppt/theme/theme2.xml><?xml version="1.0" encoding="utf-8"?>
+<a:theme xmlns:a="http://schemas.openxmlformats.org/drawingml/2006/main" name="Office 佈景主題">
+  <a:themeElements>
+    <a:clrScheme name="Office">
+      <a:dk1>
+        <a:sysClr val="windowText" lastClr="000000"/>
+      </a:dk1>
+      <a:lt1>
+        <a:sysClr val="window" lastClr="FFFFFF"/>
+      </a:lt1>
+      <a:dk2>
+        <a:srgbClr val="0E2841"/>
+      </a:dk2>
+      <a:lt2>
+        <a:srgbClr val="E8E8E8"/>
+      </a:lt2>
+      <a:accent1>
+        <a:srgbClr val="156082"/>
+      </a:accent1>
+      <a:accent2>
+        <a:srgbClr val="E97132"/>
+      </a:accent2>
+      <a:accent3>
+        <a:srgbClr val="196B24"/>
+      </a:accent3>
+      <a:accent4>
+        <a:srgbClr val="0F9ED5"/>
+      </a:accent4>
+      <a:accent5>
+        <a:srgbClr val="A02B93"/>
+      </a:accent5>
+      <a:accent6>
+        <a:srgbClr val="4EA72E"/>
+      </a:accent6>
+      <a:hlink>
+        <a:srgbClr val="467886"/>
+      </a:hlink>
+      <a:folHlink>
+        <a:srgbClr val="96607D"/>
+      </a:folHlink>
+    </a:clrScheme>
+    <a:fontScheme name="Office">
+      <a:majorFont>
+        <a:latin typeface="Aptos Display" panose="02110004020202020204"/>
+        <a:ea typeface=""/>
+        <a:cs typeface=""/>
+        <a:font script="Jpan" typeface="游ゴシック Light"/>
+        <a:font script="Hang" typeface="맑은 고딕"/>
+        <a:font script="Hans" typeface="等线 Light"/>
+        <a:font script="Hant" typeface="新細明體"/>
+        <a:font script="Arab" typeface="Times New Roman"/>
+        <a:font script="Hebr" typeface="Times New Roman"/>
+        <a:font script="Thai" typeface="Angsana New"/>
+        <a:font script="Ethi" typeface="Nyala"/>
+        <a:font script="Beng" typeface="Vrinda"/>
+        <a:font script="Gujr" typeface="Shruti"/>
+        <a:font script="Khmr" typeface="MoolBoran"/>
+        <a:font script="Knda" typeface="Tunga"/>
+        <a:font script="Guru" typeface="Raavi"/>
+        <a:font script="Cans" typeface="Euphemia"/>
+        <a:font script="Cher" typeface="Plantagenet Cherokee"/>
+        <a:font script="Yiii" typeface="Microsoft Yi Baiti"/>
+        <a:font script="Tibt" typeface="Microsoft Himalaya"/>
+        <a:font script="Thaa" typeface="MV Boli"/>
+        <a:font script="Deva" typeface="Mangal"/>
+        <a:font script="Telu" typeface="Gautami"/>
+        <a:font script="Taml" typeface="Latha"/>
+        <a:font script="Syrc" typeface="Estrangelo Edessa"/>
+        <a:font script="Orya" typeface="Kalinga"/>
+        <a:font script="Mlym" typeface="Kartika"/>
+        <a:font script="Laoo" typeface="DokChampa"/>
+        <a:font script="Sinh" typeface="Iskoola Pota"/>
+        <a:font script="Mong" typeface="Mongolian Baiti"/>
+        <a:font script="Viet" typeface="Times New Roman"/>
+        <a:font script="Uigh" typeface="Microsoft Uighur"/>
+        <a:font script="Geor" typeface="Sylfaen"/>
+        <a:font script="Armn" typeface="Arial"/>
+        <a:font script="Bugi" typeface="Leelawadee UI"/>
+        <a:font script="Bopo" typeface="Microsoft JhengHei"/>
+        <a:font script="Java" typeface="Javanese Text"/>
+        <a:font script="Lisu" typeface="Segoe UI"/>
+        <a:font script="Mymr" typeface="Myanmar Text"/>
+        <a:font script="Nkoo" typeface="Ebrima"/>
+        <a:font script="Olck" typeface="Nirmala UI"/>
+        <a:font script="Osma" typeface="Ebrima"/>
+        <a:font script="Phag" typeface="Phagspa"/>
+        <a:font script="Syrn" typeface="Estrangelo Edessa"/>
+        <a:font script="Syrj" typeface="Estrangelo Edessa"/>
+        <a:font script="Syre" typeface="Estrangelo Edessa"/>
+        <a:font script="Sora" typeface="Nirmala UI"/>
+        <a:font script="Tale" typeface="Microsoft Tai Le"/>
+        <a:font script="Talu" typeface="Microsoft New Tai Lue"/>
+        <a:font script="Tfng" typeface="Ebrima"/>
+      </a:majorFont>
+      <a:minorFont>
+        <a:latin typeface="Aptos" panose="02110004020202020204"/>
+        <a:ea typeface=""/>
+        <a:cs typeface=""/>
+        <a:font script="Jpan" typeface="游ゴシック"/>
+        <a:font script="Hang" typeface="맑은 고딕"/>
+        <a:font script="Hans" typeface="等线"/>
+        <a:font script="Hant" typeface="新細明體"/>
+        <a:font script="Arab" typeface="Arial"/>
+        <a:font script="Hebr" typeface="Arial"/>
+        <a:font script="Thai" typeface="Cordia New"/>
+        <a:font script="Ethi" typeface="Nyala"/>
+        <a:font script="Beng" typeface="Vrinda"/>
+        <a:font script="Gujr" typeface="Shruti"/>
+        <a:font script="Khmr" typeface="DaunPenh"/>
+        <a:font script="Knda" typeface="Tunga"/>
+        <a:font script="Guru" typeface="Raavi"/>
+        <a:font script="Cans" typeface="Euphemia"/>
+        <a:font script="Cher" typeface="Plantagenet Cherokee"/>
+        <a:font script="Yiii" typeface="Microsoft Yi Baiti"/>
+        <a:font script="Tibt" typeface="Microsoft Himalaya"/>
+        <a:font script="Thaa" typeface="MV Boli"/>
+        <a:font script="Deva" typeface="Mangal"/>
+        <a:font script="Telu" typeface="Gautami"/>
+        <a:font script="Taml" typeface="Latha"/>
+        <a:font script="Syrc" typeface="Estrangelo Edessa"/>
+        <a:font script="Orya" typeface="Kalinga"/>
+        <a:font script="Mlym" typeface="Kartika"/>
+        <a:font script="Laoo" typeface="DokChampa"/>
+        <a:font script="Sinh" typeface="Iskoola Pota"/>
+        <a:font script="Mong" typeface="Mongolian Baiti"/>
+        <a:font script="Viet" typeface="Arial"/>
+        <a:font script="Uigh" typeface="Microsoft Uighur"/>
+        <a:font script="Geor" typeface="Sylfaen"/>
+        <a:font script="Armn" typeface="Arial"/>
+        <a:font script="Bugi" typeface="Leelawadee UI"/>
+        <a:font script="Bopo" typeface="Microsoft JhengHei"/>
+        <a:font script="Java" typeface="Javanese Text"/>
+        <a:font script="Lisu" typeface="Segoe UI"/>
+        <a:font script="Mymr" typeface="Myanmar Text"/>
+        <a:font script="Nkoo" typeface="Ebrima"/>
+        <a:font script="Olck" typeface="Nirmala UI"/>
+        <a:font script="Osma" typeface="Ebrima"/>
+        <a:font script="Phag" typeface="Phagspa"/>
+        <a:font script="Syrn" typeface="Estrangelo Edessa"/>
+        <a:font script="Syrj" typeface="Estrangelo Edessa"/>
+        <a:font script="Syre" typeface="Estrangelo Edessa"/>
+        <a:font script="Sora" typeface="Nirmala UI"/>
+        <a:font script="Tale" typeface="Microsoft Tai Le"/>
+        <a:font script="Talu" typeface="Microsoft New Tai Lue"/>
+        <a:font script="Tfng" typeface="Ebrima"/>
+      </a:minorFont>
+    </a:fontScheme>
+    <a:fmtScheme name="Office">
+      <a:fillStyleLst>
+        <a:solidFill>
+          <a:schemeClr val="phClr"/>
+        </a:solidFill>
+        <a:gradFill rotWithShape="1">
+          <a:gsLst>
+            <a:gs pos="0">
+              <a:schemeClr val="phClr">
+                <a:lumMod val="110000"/>
+                <a:satMod val="105000"/>
+                <a:tint val="67000"/>
+              </a:schemeClr>
+            </a:gs>
+            <a:gs pos="50000">
+              <a:schemeClr val="phClr">
+                <a:lumMod val="105000"/>
+                <a:satMod val="103000"/>
+                <a:tint val="73000"/>
+              </a:schemeClr>
+            </a:gs>
+            <a:gs pos="100000">
+              <a:schemeClr val="phClr">
+                <a:lumMod val="105000"/>
+                <a:satMod val="109000"/>
+                <a:tint val="81000"/>
+              </a:schemeClr>
+            </a:gs>
+          </a:gsLst>
+          <a:lin ang="5400000" scaled="0"/>
+        </a:gradFill>
+        <a:gradFill rotWithShape="1">
+          <a:gsLst>
+            <a:gs pos="0">
+              <a:schemeClr val="phClr">
+                <a:satMod val="103000"/>
+                <a:lumMod val="102000"/>
+                <a:tint val="94000"/>
+              </a:schemeClr>
+            </a:gs>
+            <a:gs pos="50000">
+              <a:schemeClr val="phClr">
+                <a:satMod val="110000"/>
+                <a:lumMod val="100000"/>
+                <a:shade val="100000"/>
+              </a:schemeClr>
+            </a:gs>
+            <a:gs pos="100000">
+              <a:schemeClr val="phClr">
+                <a:lumMod val="99000"/>
+                <a:satMod val="120000"/>
+                <a:shade val="78000"/>
+              </a:schemeClr>
+            </a:gs>
+          </a:gsLst>
+          <a:lin ang="5400000" scaled="0"/>
+        </a:gradFill>
+      </a:fillStyleLst>
+      <a:lnStyleLst>
+        <a:ln w="12700" cap="flat" cmpd="sng" algn="ctr">
+          <a:solidFill>
+            <a:schemeClr val="phClr"/>
+          </a:solidFill>
+          <a:prstDash val="solid"/>
+          <a:miter lim="800000"/>
+        </a:ln>
+        <a:ln w="19050" cap="flat" cmpd="sng" algn="ctr">
+          <a:solidFill>
+            <a:schemeClr val="phClr"/>
+          </a:solidFill>
+          <a:prstDash val="solid"/>
+          <a:miter lim="800000"/>
+        </a:ln>
+        <a:ln w="25400" cap="flat" cmpd="sng" algn="ctr">
+          <a:solidFill>
+            <a:schemeClr val="phClr"/>
+          </a:solidFill>
+          <a:prstDash val="solid"/>
+          <a:miter lim="800000"/>
+        </a:ln>
+      </a:lnStyleLst>
+      <a:effectStyleLst>
+        <a:effectStyle>
+          <a:effectLst/>
+        </a:effectStyle>
+        <a:effectStyle>
+          <a:effectLst/>
+        </a:effectStyle>
+        <a:effectStyle>
+          <a:effectLst>
+            <a:outerShdw blurRad="57150" dist="19050" dir="5400000" algn="ctr" rotWithShape="0">
+              <a:srgbClr val="000000">
+                <a:alpha val="63000"/>
+              </a:srgbClr>
+            </a:outerShdw>
+          </a:effectLst>
+        </a:effectStyle>
+      </a:effectStyleLst>
+      <a:bgFillStyleLst>
+        <a:solidFill>
+          <a:schemeClr val="phClr"/>
+        </a:solidFill>
+        <a:solidFill>
+          <a:schemeClr val="phClr">
+            <a:tint val="95000"/>
+            <a:satMod val="170000"/>
+          </a:schemeClr>
+        </a:solidFill>
+        <a:gradFill rotWithShape="1">
+          <a:gsLst>
+            <a:gs pos="0">
+              <a:schemeClr val="phClr">
+                <a:tint val="93000"/>
+                <a:satMod val="150000"/>
+                <a:shade val="98000"/>
+                <a:lumMod val="102000"/>
+              </a:schemeClr>
+            </a:gs>
+            <a:gs pos="50000">
+              <a:schemeClr val="phClr">
+                <a:tint val="98000"/>
+                <a:satMod val="130000"/>
+                <a:shade val="90000"/>
+                <a:lumMod val="103000"/>
+              </a:schemeClr>
+            </a:gs>
+            <a:gs pos="100000">
+              <a:schemeClr val="phClr">
+                <a:shade val="63000"/>
+                <a:satMod val="120000"/>
+              </a:schemeClr>
+            </a:gs>
+          </a:gsLst>
+          <a:lin ang="5400000" scaled="0"/>
+        </a:gradFill>
+      </a:bgFillStyleLst>
+    </a:fmtScheme>
+  </a:themeElements>
+  <a:objectDefaults>
+    <a:lnDef>
+      <a:spPr/>
+      <a:bodyPr/>
+      <a:lstStyle/>
+      <a:style>
+        <a:lnRef idx="2">
+          <a:schemeClr val="accent1"/>
+        </a:lnRef>
+        <a:fillRef idx="0">
+          <a:schemeClr val="accent1"/>
+        </a:fillRef>
+        <a:effectRef idx="1">
+          <a:schemeClr val="accent1"/>
+        </a:effectRef>
+        <a:fontRef idx="minor">
+          <a:schemeClr val="tx1"/>
+        </a:fontRef>
+      </a:style>
+    </a:lnDef>
+  </a:objectDefaults>
+  <a:extraClrSchemeLst/>
+  <a:extLst>
+    <a:ext uri="{05A4C25C-085E-4340-85A3-A5531E510DB2}">
+      <thm15:themeFamily xmlns:thm15="http://schemas.microsoft.com/office/thememl/2012/main" name="Office Theme" id="{2E142A2C-CD16-42D6-873A-C26D2A0506FA}" vid="{1BDDFF52-6CD6-40A5-AB3C-68EB2F1E4D0A}"/>
+    </a:ext>
+  </a:extLst>
+</a:theme>
 </file>
</xml_diff>